<commit_message>
docs(gtm): deck v2 (drop AI-DLC, sourced cost slide, three-planes simplification) + manual deploy guide with cost model
- Aegis-SLG-EDU-Positioning-Deck.pptx: slide 10 AI-DLC removed, replaced with
  "It's Smaller Than It Looks" (three planes, 9 services / $1-3 mo / 1 deploy /
  ~10 decisions); slide 7 rewritten with sourced figures (at rest $1-3/mo;
  ~$6-8 per 1,000 governed actions, 70-85% inference; Guardrails $0.15/1k
  text units per AWS Dec-2024 announcement); notes updated
- Aegis-Manual-Deploy-and-Cost-Model.docx: the CDK stack unrolled - 11 console
  steps in dependency order, each with settings, control rationale, cost, and
  AWS doc reference; cost model A/B/C (at rest, per-1,000 actions, scenarios)

Co-Authored-By: Claude Fable 5 <noreply@anthropic.com>
Claude-Session: https://claude.ai/code/session_01H6R9E992bAAyrPQAdygUwC
</commit_message>
<xml_diff>
--- a/Aegis-SLG-EDU-Positioning-Deck.pptx
+++ b/Aegis-SLG-EDU-Positioning-Deck.pptx
@@ -601,7 +601,7 @@
           <a:p>
             <a:r>
               <a:rPr lang="en-US" dirty="0"/>
-              <a:t>TIMING ~75s. This is the AI-DLC positioning slide. The story: this wasn't a big team over years — it was disciplined AI-paired development: roughly thirty iterations per agent, each cycle tested and re-reviewed from a different critical angle, with drift-checkers so claims can never exceed evidence. Two punchlines: (1) it demonstrates the productivity your departments want from AI — governed; (2) the same lifecycle IS the onboarding path their teams follow. Transition: 'So here's what we do next.'</a:t>
+              <a:t>TIMING ~75s. This is the anti-daunting slide — use it whenever the room glazes at the component map. The move: collapse the service list into the three questions a CISO already owns (who is acting / what may happen / can you prove it), then land the four numbers — nine managed services in the core, one to three dollars a month standing still, one command to deploy, and roughly ten decisions the customer actually makes: data classes, retention per class, guardrail thresholds, who approves consequential actions, token budgets, and which IdP federates. Everything else is opinionated defaults they can change later. If asked 'what are the nine': KMS, DynamoDB x2, S3, Cognito, Lambda, CloudWatch, SSM, Bedrock — seven of which their account almost certainly runs today. Transition: 'So here are the objections you're already forming.'</a:t>
             </a:r>
             <a:endParaRPr lang="en-US" dirty="0"/>
           </a:p>
@@ -1305,7 +1305,7 @@
           <a:p>
             <a:r>
               <a:rPr lang="en-US" dirty="0"/>
-              <a:t>TIMING ~90s. Do NOT quote hard dollar figures — regions and volumes vary; the run-cost model and calculator exist precisely so their finance team fills in their own numbers. The postures to land: the platform itself is thin and serverless; the expensive thing is inference they'd buy anyway; budgets make cost a governed dimension like access; and human approval time is the honest second cost — a feature, tuned via review depth per verdict class. Transition: 'Here's how a pilot actually goes.'</a:t>
+              <a:t>TIMING ~90s. Lead with the headline: deployed and standing still, the whole governance platform is one to three dollars a month — KMS is literally the only fixed line; everything else is pay-per-use with free tiers covering pilot scale (DynamoDB first 25 GB, Cognito 10K monthly users, Lambda 1M requests). Every figure traces to an AWS pricing page; Guardrails' $0.15 per 1,000 text units is AWS's published price after the December 2024 reduction — cite it if challenged. Then the in-use story: ~$6–8 per 1,000 governed actions, 70–85% of it model inference they would buy with or without governance — so the governance premium itself is roughly a dollar per thousand actions. Budgets make cost a governed dimension like access. Close honestly: the real second cost is human approval time, and the ROI worksheet is how you tune it. Transition: 'Here's how a pilot actually goes.'</a:t>
             </a:r>
             <a:endParaRPr lang="en-US" dirty="0"/>
           </a:p>
@@ -1481,7 +1481,7 @@
           <a:p>
             <a:r>
               <a:rPr lang="en-US" dirty="0"/>
-              <a:t>TIMING ~90s. Phase 1 ends with THEIR security team running the kill-switch drill — that's the moment this stops being a slide deck for them. Phase 2's discipline: the manifest and policies are authored WITH the business owner, so governance encodes their actual rules (who signs off, what's consequential). Phase 3 is the payoff line — say it exactly: 'the second agent costs a manifest; so does the tenth.' Transition: 'A word on how this was built, because it's part of the offer.'</a:t>
+              <a:t>TIMING ~90s. Phase 1 ends with THEIR security team running the kill-switch drill — that's the moment this stops being a slide deck for them. Phase 2's discipline: the manifest and policies are authored WITH the business owner, so governance encodes their actual rules (who signs off, what's consequential). Phase 3 is the payoff line — say it exactly: 'the second agent costs a manifest; so does the tenth.' Transition: 'And if the service map still feels heavy, let me show you its honest size.'</a:t>
             </a:r>
             <a:endParaRPr lang="en-US" dirty="0"/>
           </a:p>
@@ -2122,7 +2122,7 @@
                 <a:ea typeface="Calibri" pitchFamily="34" charset="-122"/>
                 <a:cs typeface="Calibri" pitchFamily="34" charset="-120"/>
               </a:rPr>
-              <a:t>07 · HOW IT WAS BUILT</a:t>
+              <a:t>07 · COMPLEXITY, HONESTLY</a:t>
             </a:r>
             <a:endParaRPr lang="en-US" sz="1200" dirty="0"/>
           </a:p>
@@ -2161,7 +2161,7 @@
                 <a:ea typeface="Calibri" pitchFamily="34" charset="-122"/>
                 <a:cs typeface="Calibri" pitchFamily="34" charset="-120"/>
               </a:rPr>
-              <a:t>Built the Way We're Asking You to Build</a:t>
+              <a:t>It's Smaller Than It Looks</a:t>
             </a:r>
             <a:endParaRPr lang="en-US" sz="3000" dirty="0"/>
           </a:p>
@@ -2175,8 +2175,8 @@
         </p:nvSpPr>
         <p:spPr>
           <a:xfrm>
-            <a:off x="548640" y="1554480"/>
-            <a:ext cx="11064240" cy="914400"/>
+            <a:off x="548640" y="1481328"/>
+            <a:ext cx="11064240" cy="502920"/>
           </a:xfrm>
           <a:prstGeom prst="rect">
             <a:avLst/>
@@ -2190,7 +2190,7 @@
           <a:p>
             <a:pPr indent="0" marL="0">
               <a:lnSpc>
-                <a:spcPct val="112000"/>
+                <a:spcPct val="110000"/>
               </a:lnSpc>
               <a:buNone/>
             </a:pPr>
@@ -2203,7 +2203,7 @@
                 <a:ea typeface="Calibri" pitchFamily="34" charset="-122"/>
                 <a:cs typeface="Calibri" pitchFamily="34" charset="-120"/>
               </a:rPr>
-              <a:t>This platform and its agents were developed with an AI-driven development lifecycle (AI-DLC): requirements iterated conversationally with an AI pair, ~30 build-test-review cycles per agent, adversarial multi-angle reviews, and CI gates that refuse overstated claims. The same lifecycle is how your departments onboard their agents.</a:t>
+              <a:t>The service map is real — but it is not what you operate. Operationally this is three planes answering the three questions your CISO already asks, deployed as one stack.</a:t>
             </a:r>
             <a:endParaRPr lang="en-US" sz="1350" dirty="0"/>
           </a:p>
@@ -2217,12 +2217,12 @@
         </p:nvSpPr>
         <p:spPr>
           <a:xfrm>
-            <a:off x="548640" y="2743200"/>
-            <a:ext cx="3593592" cy="2377440"/>
+            <a:off x="548640" y="2148840"/>
+            <a:ext cx="3593592" cy="1965960"/>
           </a:xfrm>
           <a:prstGeom prst="roundRect">
             <a:avLst>
-              <a:gd name="adj" fmla="val 2308"/>
+              <a:gd name="adj" fmla="val 2791"/>
             </a:avLst>
           </a:prstGeom>
           <a:solidFill>
@@ -2244,7 +2244,7 @@
         </p:nvSpPr>
         <p:spPr>
           <a:xfrm>
-            <a:off x="713232" y="2852928"/>
+            <a:off x="713232" y="2258568"/>
             <a:ext cx="3264408" cy="329184"/>
           </a:xfrm>
           <a:prstGeom prst="rect">
@@ -2269,7 +2269,7 @@
                 <a:ea typeface="Calibri" pitchFamily="34" charset="-122"/>
                 <a:cs typeface="Calibri" pitchFamily="34" charset="-120"/>
               </a:rPr>
-              <a:t>Iterate with AI, gate with CI</a:t>
+              <a:t>Identity — who is acting?</a:t>
             </a:r>
             <a:endParaRPr lang="en-US" sz="1400" dirty="0"/>
           </a:p>
@@ -2283,8 +2283,8 @@
         </p:nvSpPr>
         <p:spPr>
           <a:xfrm>
-            <a:off x="713232" y="3200400"/>
-            <a:ext cx="3264408" cy="1810512"/>
+            <a:off x="713232" y="2606040"/>
+            <a:ext cx="3264408" cy="1399032"/>
           </a:xfrm>
           <a:prstGeom prst="rect">
             <a:avLst/>
@@ -2311,7 +2311,7 @@
                 <a:ea typeface="Calibri" pitchFamily="34" charset="-122"/>
                 <a:cs typeface="Calibri" pitchFamily="34" charset="-120"/>
               </a:rPr>
-              <a:t>Every capability was drafted, attacked, and re-drafted in conversation — then locked behind a negative test. AI velocity, engineering discipline.</a:t>
+              <a:t>Cognito federated to YOUR IdP, IAM, verified JWTs. Services your account already runs — zero new operational surface.</a:t>
             </a:r>
             <a:endParaRPr lang="en-US" sz="1100" dirty="0"/>
           </a:p>
@@ -2325,12 +2325,12 @@
         </p:nvSpPr>
         <p:spPr>
           <a:xfrm>
-            <a:off x="4306824" y="2743200"/>
-            <a:ext cx="3593592" cy="2377440"/>
+            <a:off x="4306824" y="2148840"/>
+            <a:ext cx="3593592" cy="1965960"/>
           </a:xfrm>
           <a:prstGeom prst="roundRect">
             <a:avLst>
-              <a:gd name="adj" fmla="val 2308"/>
+              <a:gd name="adj" fmla="val 2791"/>
             </a:avLst>
           </a:prstGeom>
           <a:solidFill>
@@ -2352,7 +2352,7 @@
         </p:nvSpPr>
         <p:spPr>
           <a:xfrm>
-            <a:off x="4471416" y="2852928"/>
+            <a:off x="4471416" y="2258568"/>
             <a:ext cx="3264408" cy="329184"/>
           </a:xfrm>
           <a:prstGeom prst="rect">
@@ -2377,7 +2377,7 @@
                 <a:ea typeface="Calibri" pitchFamily="34" charset="-122"/>
                 <a:cs typeface="Calibri" pitchFamily="34" charset="-120"/>
               </a:rPr>
-              <a:t>Review from hostile angles</a:t>
+              <a:t>Control — what may happen?</a:t>
             </a:r>
             <a:endParaRPr lang="en-US" sz="1400" dirty="0"/>
           </a:p>
@@ -2391,8 +2391,8 @@
         </p:nvSpPr>
         <p:spPr>
           <a:xfrm>
-            <a:off x="4471416" y="3200400"/>
-            <a:ext cx="3264408" cy="1810512"/>
+            <a:off x="4471416" y="2606040"/>
+            <a:ext cx="3264408" cy="1399032"/>
           </a:xfrm>
           <a:prstGeom prst="rect">
             <a:avLst/>
@@ -2419,7 +2419,7 @@
                 <a:ea typeface="Calibri" pitchFamily="34" charset="-122"/>
                 <a:cs typeface="Calibri" pitchFamily="34" charset="-120"/>
               </a:rPr>
-              <a:t>Each agent got independent review passes (security, compliance, domain) against a published bar — findings became commits, and the reviews ship in the repo.</a:t>
+              <a:t>The deny-by-default gateway: Cedar policies, the Guardrail, token budgets, the Kill Switch. One choke point — this is the platform's actual job.</a:t>
             </a:r>
             <a:endParaRPr lang="en-US" sz="1100" dirty="0"/>
           </a:p>
@@ -2433,12 +2433,12 @@
         </p:nvSpPr>
         <p:spPr>
           <a:xfrm>
-            <a:off x="8065008" y="2743200"/>
-            <a:ext cx="3593592" cy="2377440"/>
+            <a:off x="8065008" y="2148840"/>
+            <a:ext cx="3593592" cy="1965960"/>
           </a:xfrm>
           <a:prstGeom prst="roundRect">
             <a:avLst>
-              <a:gd name="adj" fmla="val 2308"/>
+              <a:gd name="adj" fmla="val 2791"/>
             </a:avLst>
           </a:prstGeom>
           <a:solidFill>
@@ -2460,7 +2460,7 @@
         </p:nvSpPr>
         <p:spPr>
           <a:xfrm>
-            <a:off x="8229600" y="2852928"/>
+            <a:off x="8229600" y="2258568"/>
             <a:ext cx="3264408" cy="329184"/>
           </a:xfrm>
           <a:prstGeom prst="rect">
@@ -2485,7 +2485,7 @@
                 <a:ea typeface="Calibri" pitchFamily="34" charset="-122"/>
                 <a:cs typeface="Calibri" pitchFamily="34" charset="-120"/>
               </a:rPr>
-              <a:t>Honesty as infrastructure</a:t>
+              <a:t>Evidence — can you prove it?</a:t>
             </a:r>
             <a:endParaRPr lang="en-US" sz="1400" dirty="0"/>
           </a:p>
@@ -2499,8 +2499,8 @@
         </p:nvSpPr>
         <p:spPr>
           <a:xfrm>
-            <a:off x="8229600" y="3200400"/>
-            <a:ext cx="3264408" cy="1810512"/>
+            <a:off x="8229600" y="2606040"/>
+            <a:ext cx="3264408" cy="1399032"/>
           </a:xfrm>
           <a:prstGeom prst="rect">
             <a:avLst/>
@@ -2527,7 +2527,7 @@
                 <a:ea typeface="Calibri" pitchFamily="34" charset="-122"/>
                 <a:cs typeface="Calibri" pitchFamily="34" charset="-120"/>
               </a:rPr>
-              <a:t>A machine-readable maturity file is the single source of truth; a drift-checker fails CI when prose claims more than tests prove. Marketing cannot outrun the code.</a:t>
+              <a:t>Append-only audit, WORM evidence bucket, CloudWatch. Write-once services that run themselves — you read them, you don't tend them.</a:t>
             </a:r>
             <a:endParaRPr lang="en-US" sz="1100" dirty="0"/>
           </a:p>
@@ -2535,46 +2535,446 @@
       </p:sp>
       <p:sp>
         <p:nvSpPr>
-          <p:cNvPr id="14" name="Text 12"/>
-          <p:cNvSpPr/>
-          <p:nvPr/>
-        </p:nvSpPr>
-        <p:spPr>
-          <a:xfrm>
-            <a:off x="548640" y="5349240"/>
-            <a:ext cx="11064240" cy="502920"/>
-          </a:xfrm>
-          <a:prstGeom prst="rect">
-            <a:avLst/>
-          </a:prstGeom>
-          <a:noFill/>
-          <a:ln/>
-        </p:spPr>
-        <p:txBody>
-          <a:bodyPr wrap="square" lIns="0" tIns="0" rIns="0" bIns="0" rtlCol="0" anchor="ctr"/>
-          <a:lstStyle/>
-          <a:p>
-            <a:pPr indent="0" marL="0">
-              <a:buNone/>
-            </a:pPr>
-            <a:r>
-              <a:rPr lang="en-US" sz="1300" i="1" dirty="0">
-                <a:solidFill>
-                  <a:srgbClr val="545B64"/>
-                </a:solidFill>
-                <a:latin typeface="Calibri" pitchFamily="34" charset="0"/>
-                <a:ea typeface="Calibri" pitchFamily="34" charset="-122"/>
-                <a:cs typeface="Calibri" pitchFamily="34" charset="-120"/>
-              </a:rPr>
-              <a:t>Why it matters to you: the same AI-DLC playbook — iterate, adversarially review, gate, prove — is the operating model your teams use on this platform.</a:t>
-            </a:r>
-            <a:endParaRPr lang="en-US" sz="1300" dirty="0"/>
-          </a:p>
-        </p:txBody>
+          <p:cNvPr id="14" name="Shape 12"/>
+          <p:cNvSpPr/>
+          <p:nvPr/>
+        </p:nvSpPr>
+        <p:spPr>
+          <a:xfrm>
+            <a:off x="548640" y="4343400"/>
+            <a:ext cx="2651760" cy="1143000"/>
+          </a:xfrm>
+          <a:prstGeom prst="roundRect">
+            <a:avLst>
+              <a:gd name="adj" fmla="val 4800"/>
+            </a:avLst>
+          </a:prstGeom>
+          <a:solidFill>
+            <a:srgbClr val="1B2A3A"/>
+          </a:solidFill>
+          <a:ln/>
+        </p:spPr>
       </p:sp>
       <p:sp>
         <p:nvSpPr>
           <p:cNvPr id="15" name="Text 13"/>
+          <p:cNvSpPr/>
+          <p:nvPr/>
+        </p:nvSpPr>
+        <p:spPr>
+          <a:xfrm>
+            <a:off x="548640" y="4434840"/>
+            <a:ext cx="2651760" cy="548640"/>
+          </a:xfrm>
+          <a:prstGeom prst="rect">
+            <a:avLst/>
+          </a:prstGeom>
+          <a:noFill/>
+          <a:ln/>
+        </p:spPr>
+        <p:txBody>
+          <a:bodyPr wrap="square" lIns="0" tIns="0" rIns="0" bIns="0" rtlCol="0" anchor="ctr"/>
+          <a:lstStyle/>
+          <a:p>
+            <a:pPr algn="ctr" indent="0" marL="0">
+              <a:buNone/>
+            </a:pPr>
+            <a:r>
+              <a:rPr lang="en-US" sz="2600" b="1" dirty="0">
+                <a:solidFill>
+                  <a:srgbClr val="F3B23E"/>
+                </a:solidFill>
+                <a:latin typeface="Calibri" pitchFamily="34" charset="0"/>
+                <a:ea typeface="Calibri" pitchFamily="34" charset="-122"/>
+                <a:cs typeface="Calibri" pitchFamily="34" charset="-120"/>
+              </a:rPr>
+              <a:t>9</a:t>
+            </a:r>
+            <a:endParaRPr lang="en-US" sz="2600" dirty="0"/>
+          </a:p>
+        </p:txBody>
+      </p:sp>
+      <p:sp>
+        <p:nvSpPr>
+          <p:cNvPr id="16" name="Text 14"/>
+          <p:cNvSpPr/>
+          <p:nvPr/>
+        </p:nvSpPr>
+        <p:spPr>
+          <a:xfrm>
+            <a:off x="640080" y="4983480"/>
+            <a:ext cx="2468880" cy="411480"/>
+          </a:xfrm>
+          <a:prstGeom prst="rect">
+            <a:avLst/>
+          </a:prstGeom>
+          <a:noFill/>
+          <a:ln/>
+        </p:spPr>
+        <p:txBody>
+          <a:bodyPr wrap="square" lIns="0" tIns="0" rIns="0" bIns="0" rtlCol="0" anchor="ctr"/>
+          <a:lstStyle/>
+          <a:p>
+            <a:pPr algn="ctr" indent="0" marL="0">
+              <a:buNone/>
+            </a:pPr>
+            <a:r>
+              <a:rPr lang="en-US" sz="1050" dirty="0">
+                <a:solidFill>
+                  <a:srgbClr val="FFFFFF"/>
+                </a:solidFill>
+                <a:latin typeface="Calibri" pitchFamily="34" charset="0"/>
+                <a:ea typeface="Calibri" pitchFamily="34" charset="-122"/>
+                <a:cs typeface="Calibri" pitchFamily="34" charset="-120"/>
+              </a:rPr>
+              <a:t>managed services in the core</a:t>
+            </a:r>
+            <a:endParaRPr lang="en-US" sz="1050" dirty="0"/>
+          </a:p>
+        </p:txBody>
+      </p:sp>
+      <p:sp>
+        <p:nvSpPr>
+          <p:cNvPr id="17" name="Shape 15"/>
+          <p:cNvSpPr/>
+          <p:nvPr/>
+        </p:nvSpPr>
+        <p:spPr>
+          <a:xfrm>
+            <a:off x="3360420" y="4343400"/>
+            <a:ext cx="2651760" cy="1143000"/>
+          </a:xfrm>
+          <a:prstGeom prst="roundRect">
+            <a:avLst>
+              <a:gd name="adj" fmla="val 4800"/>
+            </a:avLst>
+          </a:prstGeom>
+          <a:solidFill>
+            <a:srgbClr val="1B2A3A"/>
+          </a:solidFill>
+          <a:ln/>
+        </p:spPr>
+      </p:sp>
+      <p:sp>
+        <p:nvSpPr>
+          <p:cNvPr id="18" name="Text 16"/>
+          <p:cNvSpPr/>
+          <p:nvPr/>
+        </p:nvSpPr>
+        <p:spPr>
+          <a:xfrm>
+            <a:off x="3360420" y="4434840"/>
+            <a:ext cx="2651760" cy="548640"/>
+          </a:xfrm>
+          <a:prstGeom prst="rect">
+            <a:avLst/>
+          </a:prstGeom>
+          <a:noFill/>
+          <a:ln/>
+        </p:spPr>
+        <p:txBody>
+          <a:bodyPr wrap="square" lIns="0" tIns="0" rIns="0" bIns="0" rtlCol="0" anchor="ctr"/>
+          <a:lstStyle/>
+          <a:p>
+            <a:pPr algn="ctr" indent="0" marL="0">
+              <a:buNone/>
+            </a:pPr>
+            <a:r>
+              <a:rPr lang="en-US" sz="2600" b="1" dirty="0">
+                <a:solidFill>
+                  <a:srgbClr val="F3B23E"/>
+                </a:solidFill>
+                <a:latin typeface="Calibri" pitchFamily="34" charset="0"/>
+                <a:ea typeface="Calibri" pitchFamily="34" charset="-122"/>
+                <a:cs typeface="Calibri" pitchFamily="34" charset="-120"/>
+              </a:rPr>
+              <a:t>~$1–3/mo</a:t>
+            </a:r>
+            <a:endParaRPr lang="en-US" sz="2600" dirty="0"/>
+          </a:p>
+        </p:txBody>
+      </p:sp>
+      <p:sp>
+        <p:nvSpPr>
+          <p:cNvPr id="19" name="Text 17"/>
+          <p:cNvSpPr/>
+          <p:nvPr/>
+        </p:nvSpPr>
+        <p:spPr>
+          <a:xfrm>
+            <a:off x="3451860" y="4983480"/>
+            <a:ext cx="2468880" cy="411480"/>
+          </a:xfrm>
+          <a:prstGeom prst="rect">
+            <a:avLst/>
+          </a:prstGeom>
+          <a:noFill/>
+          <a:ln/>
+        </p:spPr>
+        <p:txBody>
+          <a:bodyPr wrap="square" lIns="0" tIns="0" rIns="0" bIns="0" rtlCol="0" anchor="ctr"/>
+          <a:lstStyle/>
+          <a:p>
+            <a:pPr algn="ctr" indent="0" marL="0">
+              <a:buNone/>
+            </a:pPr>
+            <a:r>
+              <a:rPr lang="en-US" sz="1050" dirty="0">
+                <a:solidFill>
+                  <a:srgbClr val="FFFFFF"/>
+                </a:solidFill>
+                <a:latin typeface="Calibri" pitchFamily="34" charset="0"/>
+                <a:ea typeface="Calibri" pitchFamily="34" charset="-122"/>
+                <a:cs typeface="Calibri" pitchFamily="34" charset="-120"/>
+              </a:rPr>
+              <a:t>standing still</a:t>
+            </a:r>
+            <a:endParaRPr lang="en-US" sz="1050" dirty="0"/>
+          </a:p>
+        </p:txBody>
+      </p:sp>
+      <p:sp>
+        <p:nvSpPr>
+          <p:cNvPr id="20" name="Shape 18"/>
+          <p:cNvSpPr/>
+          <p:nvPr/>
+        </p:nvSpPr>
+        <p:spPr>
+          <a:xfrm>
+            <a:off x="6172200" y="4343400"/>
+            <a:ext cx="2651760" cy="1143000"/>
+          </a:xfrm>
+          <a:prstGeom prst="roundRect">
+            <a:avLst>
+              <a:gd name="adj" fmla="val 4800"/>
+            </a:avLst>
+          </a:prstGeom>
+          <a:solidFill>
+            <a:srgbClr val="1B2A3A"/>
+          </a:solidFill>
+          <a:ln/>
+        </p:spPr>
+      </p:sp>
+      <p:sp>
+        <p:nvSpPr>
+          <p:cNvPr id="21" name="Text 19"/>
+          <p:cNvSpPr/>
+          <p:nvPr/>
+        </p:nvSpPr>
+        <p:spPr>
+          <a:xfrm>
+            <a:off x="6172200" y="4434840"/>
+            <a:ext cx="2651760" cy="548640"/>
+          </a:xfrm>
+          <a:prstGeom prst="rect">
+            <a:avLst/>
+          </a:prstGeom>
+          <a:noFill/>
+          <a:ln/>
+        </p:spPr>
+        <p:txBody>
+          <a:bodyPr wrap="square" lIns="0" tIns="0" rIns="0" bIns="0" rtlCol="0" anchor="ctr"/>
+          <a:lstStyle/>
+          <a:p>
+            <a:pPr algn="ctr" indent="0" marL="0">
+              <a:buNone/>
+            </a:pPr>
+            <a:r>
+              <a:rPr lang="en-US" sz="2600" b="1" dirty="0">
+                <a:solidFill>
+                  <a:srgbClr val="F3B23E"/>
+                </a:solidFill>
+                <a:latin typeface="Calibri" pitchFamily="34" charset="0"/>
+                <a:ea typeface="Calibri" pitchFamily="34" charset="-122"/>
+                <a:cs typeface="Calibri" pitchFamily="34" charset="-120"/>
+              </a:rPr>
+              <a:t>1</a:t>
+            </a:r>
+            <a:endParaRPr lang="en-US" sz="2600" dirty="0"/>
+          </a:p>
+        </p:txBody>
+      </p:sp>
+      <p:sp>
+        <p:nvSpPr>
+          <p:cNvPr id="22" name="Text 20"/>
+          <p:cNvSpPr/>
+          <p:nvPr/>
+        </p:nvSpPr>
+        <p:spPr>
+          <a:xfrm>
+            <a:off x="6263640" y="4983480"/>
+            <a:ext cx="2468880" cy="411480"/>
+          </a:xfrm>
+          <a:prstGeom prst="rect">
+            <a:avLst/>
+          </a:prstGeom>
+          <a:noFill/>
+          <a:ln/>
+        </p:spPr>
+        <p:txBody>
+          <a:bodyPr wrap="square" lIns="0" tIns="0" rIns="0" bIns="0" rtlCol="0" anchor="ctr"/>
+          <a:lstStyle/>
+          <a:p>
+            <a:pPr algn="ctr" indent="0" marL="0">
+              <a:buNone/>
+            </a:pPr>
+            <a:r>
+              <a:rPr lang="en-US" sz="1050" dirty="0">
+                <a:solidFill>
+                  <a:srgbClr val="FFFFFF"/>
+                </a:solidFill>
+                <a:latin typeface="Calibri" pitchFamily="34" charset="0"/>
+                <a:ea typeface="Calibri" pitchFamily="34" charset="-122"/>
+                <a:cs typeface="Calibri" pitchFamily="34" charset="-120"/>
+              </a:rPr>
+              <a:t>deploy (cdk deploy)</a:t>
+            </a:r>
+            <a:endParaRPr lang="en-US" sz="1050" dirty="0"/>
+          </a:p>
+        </p:txBody>
+      </p:sp>
+      <p:sp>
+        <p:nvSpPr>
+          <p:cNvPr id="23" name="Shape 21"/>
+          <p:cNvSpPr/>
+          <p:nvPr/>
+        </p:nvSpPr>
+        <p:spPr>
+          <a:xfrm>
+            <a:off x="8983980" y="4343400"/>
+            <a:ext cx="2651760" cy="1143000"/>
+          </a:xfrm>
+          <a:prstGeom prst="roundRect">
+            <a:avLst>
+              <a:gd name="adj" fmla="val 4800"/>
+            </a:avLst>
+          </a:prstGeom>
+          <a:solidFill>
+            <a:srgbClr val="1B2A3A"/>
+          </a:solidFill>
+          <a:ln/>
+        </p:spPr>
+      </p:sp>
+      <p:sp>
+        <p:nvSpPr>
+          <p:cNvPr id="24" name="Text 22"/>
+          <p:cNvSpPr/>
+          <p:nvPr/>
+        </p:nvSpPr>
+        <p:spPr>
+          <a:xfrm>
+            <a:off x="8983980" y="4434840"/>
+            <a:ext cx="2651760" cy="548640"/>
+          </a:xfrm>
+          <a:prstGeom prst="rect">
+            <a:avLst/>
+          </a:prstGeom>
+          <a:noFill/>
+          <a:ln/>
+        </p:spPr>
+        <p:txBody>
+          <a:bodyPr wrap="square" lIns="0" tIns="0" rIns="0" bIns="0" rtlCol="0" anchor="ctr"/>
+          <a:lstStyle/>
+          <a:p>
+            <a:pPr algn="ctr" indent="0" marL="0">
+              <a:buNone/>
+            </a:pPr>
+            <a:r>
+              <a:rPr lang="en-US" sz="2600" b="1" dirty="0">
+                <a:solidFill>
+                  <a:srgbClr val="F3B23E"/>
+                </a:solidFill>
+                <a:latin typeface="Calibri" pitchFamily="34" charset="0"/>
+                <a:ea typeface="Calibri" pitchFamily="34" charset="-122"/>
+                <a:cs typeface="Calibri" pitchFamily="34" charset="-120"/>
+              </a:rPr>
+              <a:t>~10</a:t>
+            </a:r>
+            <a:endParaRPr lang="en-US" sz="2600" dirty="0"/>
+          </a:p>
+        </p:txBody>
+      </p:sp>
+      <p:sp>
+        <p:nvSpPr>
+          <p:cNvPr id="25" name="Text 23"/>
+          <p:cNvSpPr/>
+          <p:nvPr/>
+        </p:nvSpPr>
+        <p:spPr>
+          <a:xfrm>
+            <a:off x="9075420" y="4983480"/>
+            <a:ext cx="2468880" cy="411480"/>
+          </a:xfrm>
+          <a:prstGeom prst="rect">
+            <a:avLst/>
+          </a:prstGeom>
+          <a:noFill/>
+          <a:ln/>
+        </p:spPr>
+        <p:txBody>
+          <a:bodyPr wrap="square" lIns="0" tIns="0" rIns="0" bIns="0" rtlCol="0" anchor="ctr"/>
+          <a:lstStyle/>
+          <a:p>
+            <a:pPr algn="ctr" indent="0" marL="0">
+              <a:buNone/>
+            </a:pPr>
+            <a:r>
+              <a:rPr lang="en-US" sz="1050" dirty="0">
+                <a:solidFill>
+                  <a:srgbClr val="FFFFFF"/>
+                </a:solidFill>
+                <a:latin typeface="Calibri" pitchFamily="34" charset="0"/>
+                <a:ea typeface="Calibri" pitchFamily="34" charset="-122"/>
+                <a:cs typeface="Calibri" pitchFamily="34" charset="-120"/>
+              </a:rPr>
+              <a:t>decisions you actually make</a:t>
+            </a:r>
+            <a:endParaRPr lang="en-US" sz="1050" dirty="0"/>
+          </a:p>
+        </p:txBody>
+      </p:sp>
+      <p:sp>
+        <p:nvSpPr>
+          <p:cNvPr id="26" name="Text 24"/>
+          <p:cNvSpPr/>
+          <p:nvPr/>
+        </p:nvSpPr>
+        <p:spPr>
+          <a:xfrm>
+            <a:off x="548640" y="5715000"/>
+            <a:ext cx="11064240" cy="411480"/>
+          </a:xfrm>
+          <a:prstGeom prst="rect">
+            <a:avLst/>
+          </a:prstGeom>
+          <a:noFill/>
+          <a:ln/>
+        </p:spPr>
+        <p:txBody>
+          <a:bodyPr wrap="square" lIns="0" tIns="0" rIns="0" bIns="0" rtlCol="0" anchor="ctr"/>
+          <a:lstStyle/>
+          <a:p>
+            <a:pPr algn="ctr" indent="0" marL="0">
+              <a:buNone/>
+            </a:pPr>
+            <a:r>
+              <a:rPr lang="en-US" sz="1400" b="1" i="1" dirty="0">
+                <a:solidFill>
+                  <a:srgbClr val="0B6E4F"/>
+                </a:solidFill>
+                <a:latin typeface="Calibri" pitchFamily="34" charset="0"/>
+                <a:ea typeface="Calibri" pitchFamily="34" charset="-122"/>
+                <a:cs typeface="Calibri" pitchFamily="34" charset="-120"/>
+              </a:rPr>
+              <a:t>You don't operate thirty services. You answer three questions — and the stack answers back with evidence.</a:t>
+            </a:r>
+            <a:endParaRPr lang="en-US" sz="1400" dirty="0"/>
+          </a:p>
+        </p:txBody>
+      </p:sp>
+      <p:sp>
+        <p:nvSpPr>
+          <p:cNvPr id="27" name="Text 25"/>
           <p:cNvSpPr/>
           <p:nvPr/>
         </p:nvSpPr>
@@ -2613,7 +3013,7 @@
       </p:sp>
       <p:sp>
         <p:nvSpPr>
-          <p:cNvPr id="16" name="Text 14"/>
+          <p:cNvPr id="28" name="Text 26"/>
           <p:cNvSpPr/>
           <p:nvPr/>
         </p:nvSpPr>
@@ -10098,7 +10498,7 @@
                 <a:ea typeface="Calibri" pitchFamily="34" charset="-122"/>
                 <a:cs typeface="Calibri" pitchFamily="34" charset="-120"/>
               </a:rPr>
-              <a:t>Thin Platform, Honest Numbers</a:t>
+              <a:t>At Rest, Pocket Change. The Meter Runs on Inference.</a:t>
             </a:r>
             <a:endParaRPr lang="en-US" sz="3000" dirty="0"/>
           </a:p>
@@ -10113,11 +10513,11 @@
         <p:spPr>
           <a:xfrm>
             <a:off x="548640" y="1600200"/>
-            <a:ext cx="5486400" cy="2103120"/>
+            <a:ext cx="5486400" cy="2286000"/>
           </a:xfrm>
           <a:prstGeom prst="roundRect">
             <a:avLst>
-              <a:gd name="adj" fmla="val 2609"/>
+              <a:gd name="adj" fmla="val 2400"/>
             </a:avLst>
           </a:prstGeom>
           <a:solidFill>
@@ -10164,7 +10564,7 @@
                 <a:ea typeface="Calibri" pitchFamily="34" charset="-122"/>
                 <a:cs typeface="Calibri" pitchFamily="34" charset="-120"/>
               </a:rPr>
-              <a:t>Deploy once</a:t>
+              <a:t>At rest: about $1–3 a month</a:t>
             </a:r>
             <a:endParaRPr lang="en-US" sz="1400" dirty="0"/>
           </a:p>
@@ -10179,7 +10579,7 @@
         <p:spPr>
           <a:xfrm>
             <a:off x="713232" y="2057400"/>
-            <a:ext cx="5157216" cy="1536192"/>
+            <a:ext cx="5157216" cy="1719072"/>
           </a:xfrm>
           <a:prstGeom prst="rect">
             <a:avLst/>
@@ -10206,7 +10606,7 @@
                 <a:ea typeface="Calibri" pitchFamily="34" charset="-122"/>
                 <a:cs typeface="Calibri" pitchFamily="34" charset="-120"/>
               </a:rPr>
-              <a:t>Serverless control plane from infrastructure-as-code (Terraform; GovCloud variant included). Each new agent deploys as four small stacks rendered from its manifest — onboarding is authoring a manifest and policies, not building infrastructure.</a:t>
+              <a:t>The control plane is serverless — no instances, no minimums. KMS key $1/mo. DynamoDB on-demand bills nothing idle (first 25 GB stored free). S3 evidence: pennies. Cognito: free to 10,000 monthly users. Lambda, the SSM kill-switch parameter, and the Guardrail cost $0 until invoked. Deployed and waiting, the platform costs less than a coffee.</a:t>
             </a:r>
             <a:endParaRPr lang="en-US" sz="1100" dirty="0"/>
           </a:p>
@@ -10221,11 +10621,11 @@
         <p:spPr>
           <a:xfrm>
             <a:off x="6172200" y="1600200"/>
-            <a:ext cx="5486400" cy="2103120"/>
+            <a:ext cx="5486400" cy="2286000"/>
           </a:xfrm>
           <a:prstGeom prst="roundRect">
             <a:avLst>
-              <a:gd name="adj" fmla="val 2609"/>
+              <a:gd name="adj" fmla="val 2400"/>
             </a:avLst>
           </a:prstGeom>
           <a:solidFill>
@@ -10272,7 +10672,7 @@
                 <a:ea typeface="Calibri" pitchFamily="34" charset="-122"/>
                 <a:cs typeface="Calibri" pitchFamily="34" charset="-120"/>
               </a:rPr>
-              <a:t>Run lean</a:t>
+              <a:t>In use: ~$6–8 per 1,000 governed actions</a:t>
             </a:r>
             <a:endParaRPr lang="en-US" sz="1400" dirty="0"/>
           </a:p>
@@ -10287,7 +10687,7 @@
         <p:spPr>
           <a:xfrm>
             <a:off x="6336792" y="2057400"/>
-            <a:ext cx="5157216" cy="1536192"/>
+            <a:ext cx="5157216" cy="1719072"/>
           </a:xfrm>
           <a:prstGeom prst="rect">
             <a:avLst/>
@@ -10314,7 +10714,7 @@
                 <a:ea typeface="Calibri" pitchFamily="34" charset="-122"/>
                 <a:cs typeface="Calibri" pitchFamily="34" charset="-120"/>
               </a:rPr>
-              <a:t>Always-on floor is modest — endpoints, keys, dashboards: typically hundreds of dollars/month at pilot scale. Everything else is per-request. The dominant variable cost is model inference — which you'd pay with or without governance.</a:t>
+              <a:t>Model inference dominates — roughly $4–5 of it at small-model prices (frontier models cost more; model choice is the biggest lever). Guardrail checks add ~$1–2 (content filters and denied topics: $0.15 per 1,000 text units). The governance plumbing itself — Lambda, audit writes, logs — is under $0.50. Inference is 70–85% of every dollar.</a:t>
             </a:r>
             <a:endParaRPr lang="en-US" sz="1100" dirty="0"/>
           </a:p>
@@ -10328,12 +10728,12 @@
         </p:nvSpPr>
         <p:spPr>
           <a:xfrm>
-            <a:off x="548640" y="3886200"/>
-            <a:ext cx="5486400" cy="2103120"/>
+            <a:off x="548640" y="4069080"/>
+            <a:ext cx="5486400" cy="1783080"/>
           </a:xfrm>
           <a:prstGeom prst="roundRect">
             <a:avLst>
-              <a:gd name="adj" fmla="val 2609"/>
+              <a:gd name="adj" fmla="val 3077"/>
             </a:avLst>
           </a:prstGeom>
           <a:solidFill>
@@ -10355,7 +10755,7 @@
         </p:nvSpPr>
         <p:spPr>
           <a:xfrm>
-            <a:off x="713232" y="3995928"/>
+            <a:off x="713232" y="4178808"/>
             <a:ext cx="5157216" cy="329184"/>
           </a:xfrm>
           <a:prstGeom prst="rect">
@@ -10380,7 +10780,7 @@
                 <a:ea typeface="Calibri" pitchFamily="34" charset="-122"/>
                 <a:cs typeface="Calibri" pitchFamily="34" charset="-120"/>
               </a:rPr>
-              <a:t>Costs you can see</a:t>
+              <a:t>Budgets make cost a policy</a:t>
             </a:r>
             <a:endParaRPr lang="en-US" sz="1400" dirty="0"/>
           </a:p>
@@ -10394,8 +10794,8 @@
         </p:nvSpPr>
         <p:spPr>
           <a:xfrm>
-            <a:off x="713232" y="4343400"/>
-            <a:ext cx="5157216" cy="1536192"/>
+            <a:off x="713232" y="4526280"/>
+            <a:ext cx="5157216" cy="1216152"/>
           </a:xfrm>
           <a:prstGeom prst="rect">
             <a:avLst/>
@@ -10422,7 +10822,7 @@
                 <a:ea typeface="Calibri" pitchFamily="34" charset="-122"/>
                 <a:cs typeface="Calibri" pitchFamily="34" charset="-120"/>
               </a:rPr>
-              <a:t>Hard token budgets per agent, alert thresholds, and chargeback by department — runaway cost is a denied call, not a surprise invoice. Line-item run-cost model + fillable calculator ship with the platform.</a:t>
+              <a:t>Hard token caps per agent, alert thresholds, chargeback by department. A runaway agent is a denied call, not a surprise invoice — cost is governed the same way access is.</a:t>
             </a:r>
             <a:endParaRPr lang="en-US" sz="1100" dirty="0"/>
           </a:p>
@@ -10436,12 +10836,12 @@
         </p:nvSpPr>
         <p:spPr>
           <a:xfrm>
-            <a:off x="6172200" y="3886200"/>
-            <a:ext cx="5486400" cy="2103120"/>
+            <a:off x="6172200" y="4069080"/>
+            <a:ext cx="5486400" cy="1783080"/>
           </a:xfrm>
           <a:prstGeom prst="roundRect">
             <a:avLst>
-              <a:gd name="adj" fmla="val 2609"/>
+              <a:gd name="adj" fmla="val 3077"/>
             </a:avLst>
           </a:prstGeom>
           <a:solidFill>
@@ -10463,7 +10863,7 @@
         </p:nvSpPr>
         <p:spPr>
           <a:xfrm>
-            <a:off x="6336792" y="3995928"/>
+            <a:off x="6336792" y="4178808"/>
             <a:ext cx="5157216" cy="329184"/>
           </a:xfrm>
           <a:prstGeom prst="rect">
@@ -10488,7 +10888,7 @@
                 <a:ea typeface="Calibri" pitchFamily="34" charset="-122"/>
                 <a:cs typeface="Calibri" pitchFamily="34" charset="-120"/>
               </a:rPr>
-              <a:t>Two honest notes</a:t>
+              <a:t>Sources &amp; honesty</a:t>
             </a:r>
             <a:endParaRPr lang="en-US" sz="1400" dirty="0"/>
           </a:p>
@@ -10502,8 +10902,8 @@
         </p:nvSpPr>
         <p:spPr>
           <a:xfrm>
-            <a:off x="6336792" y="4343400"/>
-            <a:ext cx="5157216" cy="1536192"/>
+            <a:off x="6336792" y="4526280"/>
+            <a:ext cx="5157216" cy="1216152"/>
           </a:xfrm>
           <a:prstGeom prst="rect">
             <a:avLst/>
@@ -10530,7 +10930,7 @@
                 <a:ea typeface="Calibri" pitchFamily="34" charset="-122"/>
                 <a:cs typeface="Calibri" pitchFamily="34" charset="-120"/>
               </a:rPr>
-              <a:t>The biggest lever is model choice and prompt size, not the governance layer. And the second-largest real cost is human approval time — that is a governance control working as designed, and it's the number the ROI worksheet helps you tune.</a:t>
+              <a:t>us-east-1 list prices verified Aug 2026 against AWS pricing pages and the Bedrock Guardrails pricing announcement. Your volumes vary — the run-cost calculator in the repo takes your numbers. The honest second cost is human approval time: a control working as designed.</a:t>
             </a:r>
             <a:endParaRPr lang="en-US" sz="1100" dirty="0"/>
           </a:p>

</xml_diff>

<commit_message>
docs(gtm): deck v3 (13 slides, enhanced delivery notes, onboarding slide) + agent onboarding runbook
- Aegis-SLG-EDU-Positioning-Deck.pptx: every slide's speaker notes rewritten as
  full delivery scripts (OPEN / WALK / LAND verbatim lines / IF ASKED answers /
  TRANSITION); NEW slide 10 "A New Agent Is a Runbook, Not a Project" (6-step
  onboarding pipeline + day-one inheritance band: dashboards, audit, masking,
  budget alarms, kill-switch coverage — zero observability code); footers 13
- AGENT-ONBOARDING-RUNBOOK.md: steps 0-9 from scope-with-owner to go-live
  drills, grounded in repo artifacts (MINIMUM-BAR, manifest schema, Cedar
  patterns from PV policies/, delivery_check, 4-stack cdk deploy, inherited
  observability table, condensed go-live checklist)

Co-Authored-By: Claude Fable 5 <noreply@anthropic.com>
Claude-Session: https://claude.ai/code/session_01H6R9E992bAAyrPQAdygUwC
</commit_message>
<xml_diff>
--- a/Aegis-SLG-EDU-Positioning-Deck.pptx
+++ b/Aegis-SLG-EDU-Positioning-Deck.pptx
@@ -17,9 +17,10 @@
     <p:sldId id="265" r:id="rId11"/>
     <p:sldId id="266" r:id="rId12"/>
     <p:sldId id="267" r:id="rId13"/>
+    <p:sldId id="268" r:id="rId14"/>
   </p:sldIdLst>
   <p:notesMasterIdLst>
-    <p:notesMasterId r:id="rId14"/>
+    <p:notesMasterId r:id="rId15"/>
   </p:notesMasterIdLst>
   <p:sldSz cx="12192000" cy="6858000"/>
   <p:notesSz cx="6858000" cy="12192000"/>
@@ -513,7 +514,7 @@
           <a:p>
             <a:r>
               <a:rPr lang="en-US" dirty="0"/>
-              <a:t>TIMING ~30s. One-sentence setup: your departments are already building agents — this is the platform that makes every one of them auditable, observable, least-privileged, human-gated, and stoppable. Everything in this deck exists as reviewable code with tests, deployed and exercised in clean AWS accounts. The ask at the end is a pilot of the platform plus one agent. Transition: 'Let me start with what's happening in your buildings right now.'</a:t>
+              <a:t>TIMING ~45s. OPEN: 'Every department you have is building AI agents right now — with you or without you. This deck is about the platform that makes every one of them auditable, observable, least-privileged, human-gated, and stoppable.' WALK: nothing to walk — let the tagline breathe. Make one promise early: everything shown today exists as reviewable code with passing tests, exercised in clean AWS accounts; nothing here is a concept slide. The ask at the end is deliberately small — a pilot of the platform plus one agent. LAND (say verbatim): 'Govern once. Then let every department build.' IF ASKED 'is this an AWS product?': no — an open reference architecture built on AWS services you already license; the repo's NOT-CLAIMS page says so in writing, which makes procurement simpler, not harder (code to review, not vendor claims to verify). TRANSITION: 'Let me start with what's happening in your buildings right now.'</a:t>
             </a:r>
             <a:endParaRPr lang="en-US" dirty="0"/>
           </a:p>
@@ -601,7 +602,7 @@
           <a:p>
             <a:r>
               <a:rPr lang="en-US" dirty="0"/>
-              <a:t>TIMING ~75s. This is the anti-daunting slide — use it whenever the room glazes at the component map. The move: collapse the service list into the three questions a CISO already owns (who is acting / what may happen / can you prove it), then land the four numbers — nine managed services in the core, one to three dollars a month standing still, one command to deploy, and roughly ten decisions the customer actually makes: data classes, retention per class, guardrail thresholds, who approves consequential actions, token budgets, and which IdP federates. Everything else is opinionated defaults they can change later. If asked 'what are the nine': KMS, DynamoDB x2, S3, Cognito, Lambda, CloudWatch, SSM, Bedrock — seven of which their account almost certainly runs today. Transition: 'So here are the objections you're already forming.'</a:t>
+              <a:t>TIMING ~2min. OPEN: 'This is the slide your application teams care about — what it actually takes to put a new agent on the platform.' WALK the six steps in order and emphasize the first: scoping happens with the business owner BEFORE any code, and the single most important output is the list of consequential actions — the things the agent must never do alone. Steps 2–4 are the build: copy the governed template (gateway wiring, audit, masking, and the human gate come with it), author the manifest and Cedar policies — about six artifacts total — and build only the tools the manifest declares. Step 5 is where governance bites: CI runs the nine gates, the manifest gets signed so the publisher is known, and the delivery gate refuses placeholder credentials and demo retention. Step 6: four small stacks deploy in minutes, the agent registers with the gateway, and the go-live drills run — canary, deny-by-default, kill switch. Then the green band, which is the actual sales point: LAND — 'the agent team writes business logic and evals; the dashboard, the immutable audit, the masking, the budget alarms, and the kill switch are all inherited. Zero observability code, one to two weeks, about six artifacts.' IF ASKED 'can our vendors follow this?': yes — the bar is public, the runbook ships in the repo, and signed manifests mean you always know who published what's running. TRANSITION: 'And if the whole service map still feels heavy, let me show you its honest size.'</a:t>
             </a:r>
             <a:endParaRPr lang="en-US" dirty="0"/>
           </a:p>
@@ -689,7 +690,7 @@
           <a:p>
             <a:r>
               <a:rPr lang="en-US" dirty="0"/>
-              <a:t>TIMING ~2min. Volunteer these before they're asked — the candor IS the differentiator. On 'official product': the honesty boundary makes procurement easier, not harder (no vendor claims to verify — just code to review). On 'we have IAM': agree enthusiastically, then name the agent-specific gaps one by one. On retrofits: position the nine-gate bar as their AGENT REVIEW STANDARD even for agents that never run on this platform — that reframe alone is worth the meeting. Transition: 'The ask.'</a:t>
+              <a:t>TIMING ~90s. OPEN: deploy this slide the moment anyone glazes at the component map — or proactively right here. 'The service map is real. It is also not what you operate.' WALK: collapse everything into the three questions a CISO already owns — who is acting (identity plane: their IdP, Cognito, IAM — zero new operational surface), what may happen (control plane: the gateway, Cedar, the Guardrail, budgets, the kill switch — the platform's one real job), can you prove it (evidence plane: append-only audit, WORM, CloudWatch — write-once services you read, not tend). Then the four numbers, slowly: NINE managed services in the core; ONE to three dollars a month standing still; ONE command to deploy; about TEN decisions the customer actually makes — data classes, retention per class, guardrail thresholds, who approves consequential actions, token budgets, which IdP federates. Everything else is opinionated defaults they can change later. LAND (verbatim): 'You don't operate thirty services. You answer three questions — and the stack answers back with evidence.' IF ASKED 'what are the nine?': KMS, two DynamoDB tables, S3, Cognito, Lambda, CloudWatch, SSM, Bedrock — seven of which their account almost certainly runs today. TRANSITION: 'So let me raise the objections you're already forming.'</a:t>
             </a:r>
             <a:endParaRPr lang="en-US" dirty="0"/>
           </a:p>
@@ -777,7 +778,7 @@
           <a:p>
             <a:r>
               <a:rPr lang="en-US" dirty="0"/>
-              <a:t>TIMING ~60s then discussion. The ask is deliberately small: one pilot, one agent, weeks not quarters — because the platform exists and deploys from IaC. Step 4 is the strategic hook: even before broad rollout, adopting the nine-gate bar as their agency-wide agent standard changes their posture immediately, costs nothing, and makes this platform the natural home for everything that clears it. Close on the tagline and stop talking.</a:t>
+              <a:t>TIMING ~2.5min. OPEN: 'Let me raise the objections for you — because the candor is the point.' WALK each one. 'This isn't an official AWS product': correct, and the repo says so in writing — which makes procurement EASIER: there are no vendor claims to verify, only code to review, and their security team can read every line before trusting any of it. 'We already have IAM': agree enthusiastically — IAM is the foundation — then name what IAM alone doesn't give an agent: the agent-and-human permission intersection, a human gate with single-use bound approvals, masking at the prompt boundary, per-agent token budgets, and a platform-wide kill switch. 'What about agents we already have?': the nine-gate bar works as their AGENT REVIEW STANDARD even for agents that never run on this platform — adopting the bar costs nothing and changes their posture immediately; that reframe alone is worth the meeting. LAND: 'Everything I just told you is checkable. That's the difference.' TRANSITION: 'So here's the ask.'</a:t>
             </a:r>
             <a:endParaRPr lang="en-US" dirty="0"/>
           </a:p>
@@ -801,6 +802,94 @@
             <a:fld id="{F7021451-1387-4CA6-816F-3879F97B5CBC}" type="slidenum">
               <a:rPr lang="en-US"/>
               <a:t>12</a:t>
+            </a:fld>
+            <a:endParaRPr lang="en-US"/>
+          </a:p>
+        </p:txBody>
+      </p:sp>
+    </p:spTree>
+    <p:extLst>
+      <p:ext uri="{BB962C8B-B14F-4D97-AF65-F5344CB8AC3E}">
+        <p14:creationId xmlns:p14="http://schemas.microsoft.com/office/powerpoint/2010/main" val="1024086991"/>
+      </p:ext>
+    </p:extLst>
+  </p:cSld>
+  <p:clrMapOvr>
+    <a:masterClrMapping/>
+  </p:clrMapOvr>
+</p:notes>
+</file>
+
+<file path=ppt/notesSlides/notesSlide13.xml><?xml version="1.0" encoding="utf-8"?>
+<p:notes xmlns:a="http://schemas.openxmlformats.org/drawingml/2006/main" xmlns:r="http://schemas.openxmlformats.org/officeDocument/2006/relationships" xmlns:p="http://schemas.openxmlformats.org/presentationml/2006/main">
+  <p:cSld>
+    <p:spTree>
+      <p:nvGrpSpPr>
+        <p:cNvPr id="1" name=""/>
+        <p:cNvGrpSpPr/>
+        <p:nvPr/>
+      </p:nvGrpSpPr>
+      <p:grpSpPr>
+        <a:xfrm>
+          <a:off x="0" y="0"/>
+          <a:ext cx="0" cy="0"/>
+          <a:chOff x="0" y="0"/>
+          <a:chExt cx="0" cy="0"/>
+        </a:xfrm>
+      </p:grpSpPr>
+      <p:sp>
+        <p:nvSpPr>
+          <p:cNvPr id="2" name="Slide Image Placeholder 1"/>
+          <p:cNvSpPr>
+            <a:spLocks noGrp="1" noRot="1" noChangeAspect="1"/>
+          </p:cNvSpPr>
+          <p:nvPr>
+            <p:ph type="sldImg"/>
+          </p:nvPr>
+        </p:nvSpPr>
+        <p:spPr/>
+      </p:sp>
+      <p:sp>
+        <p:nvSpPr>
+          <p:cNvPr id="3" name="Notes Placeholder 2"/>
+          <p:cNvSpPr>
+            <a:spLocks noGrp="1"/>
+          </p:cNvSpPr>
+          <p:nvPr>
+            <p:ph type="body" idx="1"/>
+          </p:nvPr>
+        </p:nvSpPr>
+        <p:spPr/>
+        <p:txBody>
+          <a:bodyPr/>
+          <a:lstStyle/>
+          <a:p>
+            <a:r>
+              <a:rPr lang="en-US" dirty="0"/>
+              <a:t>TIMING ~60s, then stop and let the room talk. OPEN: 'The ask is small on purpose.' WALK: one pilot — the platform plus one agent — in weeks, not quarters, because the platform already exists and deploys from IaC in minutes; their security team runs the kill-switch drill in week one, and the first agent is authored WITH their business owner. The strategic hook is step 4: even before any rollout, adopt the nine-gate bar as the agency-wide agent review standard — it costs nothing, changes their posture immediately, and makes this platform the natural home for everything that clears it. IF ASKED 'what do you need from us?': three things — an AWS account, an IdP admin for an afternoon, and one department with one reachable system of record. LAND: close on the tagline — 'Govern once. Then let every department build.' — and stop talking. The next voice should be theirs.</a:t>
+            </a:r>
+            <a:endParaRPr lang="en-US" dirty="0"/>
+          </a:p>
+        </p:txBody>
+      </p:sp>
+      <p:sp>
+        <p:nvSpPr>
+          <p:cNvPr id="4" name="Slide Number Placeholder 3"/>
+          <p:cNvSpPr>
+            <a:spLocks noGrp="1"/>
+          </p:cNvSpPr>
+          <p:nvPr>
+            <p:ph type="sldNum" sz="quarter" idx="10"/>
+          </p:nvPr>
+        </p:nvSpPr>
+        <p:spPr/>
+        <p:txBody>
+          <a:bodyPr/>
+          <a:lstStyle/>
+          <a:p>
+            <a:fld id="{F7021451-1387-4CA6-816F-3879F97B5CBC}" type="slidenum">
+              <a:rPr lang="en-US"/>
+              <a:t>13</a:t>
             </a:fld>
             <a:endParaRPr lang="en-US"/>
           </a:p>
@@ -865,7 +954,7 @@
           <a:p>
             <a:r>
               <a:rPr lang="en-US" dirty="0"/>
-              <a:t>TIMING ~90s. Land each card as recognition, not accusation — every agency in the room has shadow agents. The four questions in the top-right card are the exact questions counsel and auditors ask; say them slowly. The amber card is the emotional center of the deck: ask the kill-switch question out loud and pause. Most rooms go quiet. Transition: 'Here's the inversion that fixes the economics.'</a:t>
+              <a:t>TIMING ~2min. OPEN with recognition, not accusation: 'You already have these. Every agency does.' WALK the cards clockwise. Shadow agents: each one works in a demo, each is wired differently, none is visible to central IT until something goes wrong — name their own examples if you know them (benefits screener, records triage). Four questions: read them SLOWLY, one per breath — who did it act for, what can it reach, who approved that, where's the tamper-proof record — these are counsel's questions verbatim, not IT's. One-off reviews: no shared controls means every agent is a bespoke risk assessment; reviews take months, departments route around them, and the risk compounds quietly. Then the amber card. LAND: ask the 2am question out loud — 'if an agent misbehaves at 2am, can you stop everything, right now, and prove you did?' — then count three silent beats. Do not fill the silence; the room will. IF ASKED 'we have an AI policy': a policy tells people what they should do; a platform makes the wrong thing impossible — ask them how the policy is enforced at 2am on a Saturday. TRANSITION: 'Here's the inversion that fixes the economics.'</a:t>
             </a:r>
             <a:endParaRPr lang="en-US" dirty="0"/>
           </a:p>
@@ -953,7 +1042,7 @@
           <a:p>
             <a:r>
               <a:rPr lang="en-US" dirty="0"/>
-              <a:t>TIMING ~90s. Walk the pipeline left to right in one breath — the point is that EVERY action crosses ALL of it. Then the two cards: the intersection rule is the sentence CISOs remember ('an agent never exceeds the authority of the human it acts for'); the kill switch answers slide 2's meeting-ender — one command, audited, and the person who engaged it cannot be the one who releases it. Transition: 'You already own most of the pieces.'</a:t>
+              <a:t>TIMING ~2min. OPEN: 'One control plane. Every agent through it. Deny by default.' WALK: sweep the seven-stage pipeline left to right in a single breath first — the visual point is that EVERY action, every model call, tool call, and retrieval, crosses ALL of it — then slow down and touch three stages by name: least-privilege intersection, the human gate, the append-only audit. Then the two cards. Intersection rule — say it verbatim, it's the sentence CISOs repeat in their own meetings later: 'An agent never exceeds the authority of the human it acts for.' Kill switch — this answers slide 2's meeting-ender: one command denies everything platform-wide, it's audited, and the person who engaged it cannot be the person who releases it; it's drilled quarterly, not just documented. LAND: 'Build the platform once — every agent after that is configuration that inherits governance, not a project that reinvents it.' IF ASKED 'what is AGP v1.0?': a versioned governance contract — eight fail-closed controls, each proven by a negative test. Your reviewers approve the pattern once; after that they check conformance, not architecture. That's what collapses review time. TRANSITION: 'And here's the part that surprises people: you already own most of the pieces.'</a:t>
             </a:r>
             <a:endParaRPr lang="en-US" dirty="0"/>
           </a:p>
@@ -1041,7 +1130,7 @@
           <a:p>
             <a:r>
               <a:rPr lang="en-US" dirty="0"/>
-              <a:t>TIMING ~2min. This slide converts skeptics: nothing exotic, no new vendor — services they already license and audit, assembled with a thin open platform layer that makes behavior fail-closed and testable. Read two rows fully (identity, containment) and let them scan the rest. Note the direction of travel: what began as platform code increasingly has managed equivalents (AgentCore Gateway, Cedar policy engine), so the custom layer keeps shrinking toward manifests, policies, and tests — the parts that encode THEIR governance. GovCloud variant exists in the IaC. Transition: 'And when a new agent shows up, here's the bar it clears.'</a:t>
+              <a:t>TIMING ~2.5min. OPEN: 'Nothing on this slide is exotic. There is no new vendor here.' WALK: read exactly two rows end-to-end and let them scan the rest. Row one, Identity: Cognito federates to the IdP they already run (Entra), so every agent action is attributable to a verified person — start here because it's the row they already trust. Row eight, Containment: SSM parameter + two-role IAM separation + KMS = the kill switch from slide 3, now shown as the boring services it's made of. Point at the third column as you go: each row is bought for an OUTCOME, not for the service's own sake. Then the direction of travel: what began as platform code increasingly has managed equivalents — AgentCore Gateway for the tool boundary, the Cedar policy engine for authorization — so the custom layer keeps shrinking toward manifests, policies, and tests: the parts that encode THEIR rules, which is the only part that should ever be custom. GovCloud variant ships in the IaC. LAND: 'You already license and audit every service on this slide. What's new is the assembly — and the discipline.' IF ASKED 'is AgentCore required?': no — the reference implementation runs on plain Lambda and Step Functions; AgentCore primitives are the managed path where available, HIPAA-eligible per AWS's compliance documentation. TRANSITION: 'And when a new agent shows up — yours or a vendor's — here's the bar it clears.'</a:t>
             </a:r>
             <a:endParaRPr lang="en-US" dirty="0"/>
           </a:p>
@@ -1129,7 +1218,7 @@
           <a:p>
             <a:r>
               <a:rPr lang="en-US" dirty="0"/>
-              <a:t>TIMING ~90s. The governance question every vendor add-on raises — 'can we trust this thing?' — becomes mechanical: does it clear the bar? Emphasize gate 2 (consequential actions absent from the agent's own tool grants — 'can the AI act alone' is answerably NO in code) and gate 8 (signed manifests: you know who published every agent). Enforcement is layered: CI at build, gateway at runtime, delivery gate at handoff. Transition: 'This isn't a diagram — it runs. Here's the proof.'</a:t>
+              <a:t>TIMING ~2min. OPEN: 'Every new agent raises the same question — can we trust this thing? The bar makes that question mechanical: does it clear nine gates?' WALK: don't read all nine — spotlight three. Gate 2, consequential actions withheld in code: the issue/adjudicate/release actions are ABSENT from the agent's own tool grants and reachable only through the human gate — so 'can the AI act alone?' is answerably NO, in code, in a way that survives an audit. Gate 8, signed manifests: you know who published every agent running in your environment — including vendors'. Gate 5, hard token budgets: cost is a governed dimension, not a surprise. Then the dark band — enforcement is layered and none of it is manners: CI rejects at build, the gateway refuses to load at runtime, and a delivery gate blocks placeholder credentials, demo retention, and unsigned manifests from ever reaching production. LAND: 'Gates, not guidelines. An agent that fails any gate does not load.' IF ASKED 'who maintains the bar?': it's versioned in the repo; your platform team owns it after adoption, and changes to the bar go through the same CI as everything else. TRANSITION: 'This isn't a diagram — it runs. Here's the proof.'</a:t>
             </a:r>
             <a:endParaRPr lang="en-US" dirty="0"/>
           </a:p>
@@ -1217,7 +1306,7 @@
           <a:p>
             <a:r>
               <a:rPr lang="en-US" dirty="0"/>
-              <a:t>TIMING ~90s. Four working agents, three verticals, one template — the platform claim is demonstrated, not asserted. The right card is a differentiator with public-sector buyers: a written honesty boundary (NOT-CLAIMS), a machine-readable maturity file that CI enforces against overstatement, and runtime evidence from clean-account deployments. Offer the live demo: the clean-account acceptance script runs the entire control plane end-to-end in front of them — deny unauthorized tool, block self-approval, reject replay, prove immutable audit. Transition: 'What does this cost?'</a:t>
+              <a:t>TIMING ~2min. OPEN: 'Demonstrated, not asserted.' WALK: four working agents, three verticals, one IDENTICAL template. Point at pharmacovigilance and use it deliberately: drug-safety intake is the regulated-industry stress test — if ICH-grade pharmacovigilance clears this bar, a benefits screener will. Then the honesty card, slowly, because it's the differentiator with public-sector buyers: a written honesty boundary (NOT-CLAIMS — what we will NOT say), a machine-readable maturity file that CI enforces so prose can never claim more than tests prove, and retained deploy/invoke/prove evidence from clean AWS accounts. No vendor deck in their pile does this. LAND: 'Each agent is one manifest, a set of policies, its tools, and its tests. Same template, different domain — that is the platform working.' OFFER: the ten-minute live demo — the clean-account acceptance script runs the whole control plane in front of them: deny an unauthorized tool, block a self-approval, reject a replayed approval, prove the audit is immutable. Their account or ours. TRANSITION: 'So what does this cost?'</a:t>
             </a:r>
             <a:endParaRPr lang="en-US" dirty="0"/>
           </a:p>
@@ -1305,7 +1394,7 @@
           <a:p>
             <a:r>
               <a:rPr lang="en-US" dirty="0"/>
-              <a:t>TIMING ~90s. Lead with the headline: deployed and standing still, the whole governance platform is one to three dollars a month — KMS is literally the only fixed line; everything else is pay-per-use with free tiers covering pilot scale (DynamoDB first 25 GB, Cognito 10K monthly users, Lambda 1M requests). Every figure traces to an AWS pricing page; Guardrails' $0.15 per 1,000 text units is AWS's published price after the December 2024 reduction — cite it if challenged. Then the in-use story: ~$6–8 per 1,000 governed actions, 70–85% of it model inference they would buy with or without governance — so the governance premium itself is roughly a dollar per thousand actions. Budgets make cost a governed dimension like access. Close honestly: the real second cost is human approval time, and the ROI worksheet is how you tune it. Transition: 'Here's how a pilot actually goes.'</a:t>
+              <a:t>TIMING ~2min. OPEN with the headline number and stop: 'Deployed and standing still, this whole platform costs one to three dollars a month.' Let it land — it's the number that kills the daunting feeling. WALK: at rest, KMS's $1 key fee is literally the only fixed line; DynamoDB bills nothing idle (first 25 GB free), Cognito is free to 10,000 monthly users, Lambda to a million requests, and the Guardrail costs nothing until invoked. Then in use: roughly $6–8 per 1,000 governed actions — and decompose it out loud: $4–5 is model inference they would buy with or without governance; ~$1.20 is guardrail checks; the governance plumbing itself is under fifty cents. So the governance premium is about a dollar per thousand actions. Budgets card: hard caps make a runaway agent a denied call, not a surprise invoice. LAND: 'The expensive part was never the platform — it's inference you'd buy anyway, and even that arrives with a budget around it.' IF CHALLENGED on figures: every number traces to an AWS pricing page; Guardrails' $0.15 per 1,000 text units is AWS's published price after the December 2024 reduction; the manual-deploy guide in the repo carries the citations line by line, and the calculator takes THEIR volumes. Honest close: the real second cost is human approval time — a control working as designed, tuned in the ROI worksheet. TRANSITION: 'Here's the other half of readiness — your data.'</a:t>
             </a:r>
             <a:endParaRPr lang="en-US" dirty="0"/>
           </a:p>
@@ -1393,7 +1482,7 @@
           <a:p>
             <a:r>
               <a:rPr lang="en-US" dirty="0"/>
-              <a:t>TIMING ~75s. This slide pre-empts the 'our data isn't ready' objection honestly: you don't need a two-year data program — you need ONE reachable system of record for the first agent, and the connector-maturity discipline keeps everyone honest about which integrations are live vs. engagement work. The data-classification point matters to CISOs: classify once in the manifest, and masking/retention/policy follow automatically. Transition: 'The rollout.'</a:t>
+              <a:t>TIMING ~90s. OPEN by naming the objection before they do: 'The next thought in the room is usually — our data isn't ready.' WALK: the honest answer is you don't need a two-year data program; you need ONE reachable system of record with an API and an owner, for one agent. The connector-maturity discipline keeps everyone honest about the rest: every integration is declared live, reference, or stubbed in a machine-readable file — no hand-waving about what's actually connected. Then the classification point, which is the CISO's favorite: each dataset is classified once in the manifest — PII, FERPA, PHI, CJI — and masking behavior, audit retention, and Cedar policy selection follow from the classification automatically. Governance follows the data. LAND: 'Start where the data is ready — one system, one accountable department. The platform doesn't wait for a data lake.' IF ASKED about FERPA/CJIS/HIPAA specifically: data classes are exactly how those obligations attach; the hardened identity profile notes CJIS's MFA mandate, and the stack is HIPAA-eligible where PHI is in scope. TRANSITION: 'So here's how a rollout actually goes.'</a:t>
             </a:r>
             <a:endParaRPr lang="en-US" dirty="0"/>
           </a:p>
@@ -1481,7 +1570,7 @@
           <a:p>
             <a:r>
               <a:rPr lang="en-US" dirty="0"/>
-              <a:t>TIMING ~90s. Phase 1 ends with THEIR security team running the kill-switch drill — that's the moment this stops being a slide deck for them. Phase 2's discipline: the manifest and policies are authored WITH the business owner, so governance encodes their actual rules (who signs off, what's consequential). Phase 3 is the payoff line — say it exactly: 'the second agent costs a manifest; so does the tenth.' Transition: 'And if the service map still feels heavy, let me show you its honest size.'</a:t>
+              <a:t>TIMING ~2min. OPEN: 'Platform first. Then agents as configuration.' WALK the three phases with one emphasis each. Phase 1: it ends with THEIR security team running the kill-switch drill themselves — engage, watch everything deny, release with a second identity, read the audit — that is the moment this stops being a slide deck for them. Phase 2: the manifest and Cedar policies are authored WITH the business owner, not for them — so governance encodes their actual rules: who signs off, what counts as consequential, how deep review goes. Phase 3: onboarding becomes a runbook — and vendor add-ons clear the same bar as in-house agents, signed manifests and all. LAND (say it exactly): 'The second agent costs a manifest. So does the tenth.' IF ASKED about timeline: four to six weeks for the platform, the same for the first agent, then one to two weeks per agent after that — and the next slide is literally that runbook. TRANSITION: 'Here's what onboarding an agent actually looks like.'</a:t>
             </a:r>
             <a:endParaRPr lang="en-US" dirty="0"/>
           </a:p>
@@ -2122,7 +2211,7 @@
                 <a:ea typeface="Calibri" pitchFamily="34" charset="-122"/>
                 <a:cs typeface="Calibri" pitchFamily="34" charset="-120"/>
               </a:rPr>
-              <a:t>07 · COMPLEXITY, HONESTLY</a:t>
+              <a:t>07 · ONBOARDING</a:t>
             </a:r>
             <a:endParaRPr lang="en-US" sz="1200" dirty="0"/>
           </a:p>
@@ -2161,7 +2250,7 @@
                 <a:ea typeface="Calibri" pitchFamily="34" charset="-122"/>
                 <a:cs typeface="Calibri" pitchFamily="34" charset="-120"/>
               </a:rPr>
-              <a:t>It's Smaller Than It Looks</a:t>
+              <a:t>A New Agent Is a Runbook, Not a Project</a:t>
             </a:r>
             <a:endParaRPr lang="en-US" sz="3000" dirty="0"/>
           </a:p>
@@ -2169,60 +2258,18 @@
       </p:sp>
       <p:sp>
         <p:nvSpPr>
-          <p:cNvPr id="4" name="Text 2"/>
-          <p:cNvSpPr/>
-          <p:nvPr/>
-        </p:nvSpPr>
-        <p:spPr>
-          <a:xfrm>
-            <a:off x="548640" y="1481328"/>
-            <a:ext cx="11064240" cy="502920"/>
-          </a:xfrm>
-          <a:prstGeom prst="rect">
-            <a:avLst/>
-          </a:prstGeom>
-          <a:noFill/>
-          <a:ln/>
-        </p:spPr>
-        <p:txBody>
-          <a:bodyPr wrap="square" lIns="0" tIns="0" rIns="0" bIns="0" rtlCol="0" anchor="ctr"/>
-          <a:lstStyle/>
-          <a:p>
-            <a:pPr indent="0" marL="0">
-              <a:lnSpc>
-                <a:spcPct val="110000"/>
-              </a:lnSpc>
-              <a:buNone/>
-            </a:pPr>
-            <a:r>
-              <a:rPr lang="en-US" sz="1350" dirty="0">
-                <a:solidFill>
-                  <a:srgbClr val="545B64"/>
-                </a:solidFill>
-                <a:latin typeface="Calibri" pitchFamily="34" charset="0"/>
-                <a:ea typeface="Calibri" pitchFamily="34" charset="-122"/>
-                <a:cs typeface="Calibri" pitchFamily="34" charset="-120"/>
-              </a:rPr>
-              <a:t>The service map is real — but it is not what you operate. Operationally this is three planes answering the three questions your CISO already asks, deployed as one stack.</a:t>
-            </a:r>
-            <a:endParaRPr lang="en-US" sz="1350" dirty="0"/>
-          </a:p>
-        </p:txBody>
-      </p:sp>
-      <p:sp>
-        <p:nvSpPr>
-          <p:cNvPr id="5" name="Shape 3"/>
-          <p:cNvSpPr/>
-          <p:nvPr/>
-        </p:nvSpPr>
-        <p:spPr>
-          <a:xfrm>
-            <a:off x="548640" y="2148840"/>
-            <a:ext cx="3593592" cy="1965960"/>
+          <p:cNvPr id="4" name="Shape 2"/>
+          <p:cNvSpPr/>
+          <p:nvPr/>
+        </p:nvSpPr>
+        <p:spPr>
+          <a:xfrm>
+            <a:off x="548640" y="1572768"/>
+            <a:ext cx="3593592" cy="1353312"/>
           </a:xfrm>
           <a:prstGeom prst="roundRect">
             <a:avLst>
-              <a:gd name="adj" fmla="val 2791"/>
+              <a:gd name="adj" fmla="val 3378"/>
             </a:avLst>
           </a:prstGeom>
           <a:solidFill>
@@ -2238,53 +2285,53 @@
       </p:sp>
       <p:sp>
         <p:nvSpPr>
+          <p:cNvPr id="5" name="Text 3"/>
+          <p:cNvSpPr/>
+          <p:nvPr/>
+        </p:nvSpPr>
+        <p:spPr>
+          <a:xfrm>
+            <a:off x="694944" y="1664208"/>
+            <a:ext cx="3291840" cy="310896"/>
+          </a:xfrm>
+          <a:prstGeom prst="rect">
+            <a:avLst/>
+          </a:prstGeom>
+          <a:noFill/>
+          <a:ln/>
+        </p:spPr>
+        <p:txBody>
+          <a:bodyPr wrap="square" lIns="0" tIns="0" rIns="0" bIns="0" rtlCol="0" anchor="ctr"/>
+          <a:lstStyle/>
+          <a:p>
+            <a:pPr indent="0" marL="0">
+              <a:buNone/>
+            </a:pPr>
+            <a:r>
+              <a:rPr lang="en-US" sz="1250" b="1" dirty="0">
+                <a:solidFill>
+                  <a:srgbClr val="1B2A3A"/>
+                </a:solidFill>
+                <a:latin typeface="Calibri" pitchFamily="34" charset="0"/>
+                <a:ea typeface="Calibri" pitchFamily="34" charset="-122"/>
+                <a:cs typeface="Calibri" pitchFamily="34" charset="-120"/>
+              </a:rPr>
+              <a:t>1 · Scope with the owner</a:t>
+            </a:r>
+            <a:endParaRPr lang="en-US" sz="1250" dirty="0"/>
+          </a:p>
+        </p:txBody>
+      </p:sp>
+      <p:sp>
+        <p:nvSpPr>
           <p:cNvPr id="6" name="Text 4"/>
           <p:cNvSpPr/>
           <p:nvPr/>
         </p:nvSpPr>
         <p:spPr>
           <a:xfrm>
-            <a:off x="713232" y="2258568"/>
-            <a:ext cx="3264408" cy="329184"/>
-          </a:xfrm>
-          <a:prstGeom prst="rect">
-            <a:avLst/>
-          </a:prstGeom>
-          <a:noFill/>
-          <a:ln/>
-        </p:spPr>
-        <p:txBody>
-          <a:bodyPr wrap="square" lIns="0" tIns="0" rIns="0" bIns="0" rtlCol="0" anchor="ctr"/>
-          <a:lstStyle/>
-          <a:p>
-            <a:pPr indent="0" marL="0">
-              <a:buNone/>
-            </a:pPr>
-            <a:r>
-              <a:rPr lang="en-US" sz="1400" b="1" dirty="0">
-                <a:solidFill>
-                  <a:srgbClr val="1B2A3A"/>
-                </a:solidFill>
-                <a:latin typeface="Calibri" pitchFamily="34" charset="0"/>
-                <a:ea typeface="Calibri" pitchFamily="34" charset="-122"/>
-                <a:cs typeface="Calibri" pitchFamily="34" charset="-120"/>
-              </a:rPr>
-              <a:t>Identity — who is acting?</a:t>
-            </a:r>
-            <a:endParaRPr lang="en-US" sz="1400" dirty="0"/>
-          </a:p>
-        </p:txBody>
-      </p:sp>
-      <p:sp>
-        <p:nvSpPr>
-          <p:cNvPr id="7" name="Text 5"/>
-          <p:cNvSpPr/>
-          <p:nvPr/>
-        </p:nvSpPr>
-        <p:spPr>
-          <a:xfrm>
-            <a:off x="713232" y="2606040"/>
-            <a:ext cx="3264408" cy="1399032"/>
+            <a:off x="694944" y="1993392"/>
+            <a:ext cx="3310128" cy="868680"/>
           </a:xfrm>
           <a:prstGeom prst="rect">
             <a:avLst/>
@@ -2298,12 +2345,12 @@
           <a:p>
             <a:pPr indent="0" marL="0">
               <a:lnSpc>
-                <a:spcPct val="108000"/>
+                <a:spcPct val="105000"/>
               </a:lnSpc>
               <a:buNone/>
             </a:pPr>
             <a:r>
-              <a:rPr lang="en-US" sz="1100" dirty="0">
+              <a:rPr lang="en-US" sz="1050" dirty="0">
                 <a:solidFill>
                   <a:srgbClr val="545B64"/>
                 </a:solidFill>
@@ -2311,26 +2358,26 @@
                 <a:ea typeface="Calibri" pitchFamily="34" charset="-122"/>
                 <a:cs typeface="Calibri" pitchFamily="34" charset="-120"/>
               </a:rPr>
-              <a:t>Cognito federated to YOUR IdP, IAM, verified JWTs. Services your account already runs — zero new operational surface.</a:t>
-            </a:r>
-            <a:endParaRPr lang="en-US" sz="1100" dirty="0"/>
-          </a:p>
-        </p:txBody>
-      </p:sp>
-      <p:sp>
-        <p:nvSpPr>
-          <p:cNvPr id="8" name="Shape 6"/>
-          <p:cNvSpPr/>
-          <p:nvPr/>
-        </p:nvSpPr>
-        <p:spPr>
-          <a:xfrm>
-            <a:off x="4306824" y="2148840"/>
-            <a:ext cx="3593592" cy="1965960"/>
+              <a:t>Name the purpose, the data classes, and every consequential action — before any code.</a:t>
+            </a:r>
+            <a:endParaRPr lang="en-US" sz="1050" dirty="0"/>
+          </a:p>
+        </p:txBody>
+      </p:sp>
+      <p:sp>
+        <p:nvSpPr>
+          <p:cNvPr id="7" name="Shape 5"/>
+          <p:cNvSpPr/>
+          <p:nvPr/>
+        </p:nvSpPr>
+        <p:spPr>
+          <a:xfrm>
+            <a:off x="4306824" y="1572768"/>
+            <a:ext cx="3593592" cy="1353312"/>
           </a:xfrm>
           <a:prstGeom prst="roundRect">
             <a:avLst>
-              <a:gd name="adj" fmla="val 2791"/>
+              <a:gd name="adj" fmla="val 3378"/>
             </a:avLst>
           </a:prstGeom>
           <a:solidFill>
@@ -2346,53 +2393,53 @@
       </p:sp>
       <p:sp>
         <p:nvSpPr>
+          <p:cNvPr id="8" name="Text 6"/>
+          <p:cNvSpPr/>
+          <p:nvPr/>
+        </p:nvSpPr>
+        <p:spPr>
+          <a:xfrm>
+            <a:off x="4453128" y="1664208"/>
+            <a:ext cx="3291840" cy="310896"/>
+          </a:xfrm>
+          <a:prstGeom prst="rect">
+            <a:avLst/>
+          </a:prstGeom>
+          <a:noFill/>
+          <a:ln/>
+        </p:spPr>
+        <p:txBody>
+          <a:bodyPr wrap="square" lIns="0" tIns="0" rIns="0" bIns="0" rtlCol="0" anchor="ctr"/>
+          <a:lstStyle/>
+          <a:p>
+            <a:pPr indent="0" marL="0">
+              <a:buNone/>
+            </a:pPr>
+            <a:r>
+              <a:rPr lang="en-US" sz="1250" b="1" dirty="0">
+                <a:solidFill>
+                  <a:srgbClr val="1B2A3A"/>
+                </a:solidFill>
+                <a:latin typeface="Calibri" pitchFamily="34" charset="0"/>
+                <a:ea typeface="Calibri" pitchFamily="34" charset="-122"/>
+                <a:cs typeface="Calibri" pitchFamily="34" charset="-120"/>
+              </a:rPr>
+              <a:t>2 · Copy the template</a:t>
+            </a:r>
+            <a:endParaRPr lang="en-US" sz="1250" dirty="0"/>
+          </a:p>
+        </p:txBody>
+      </p:sp>
+      <p:sp>
+        <p:nvSpPr>
           <p:cNvPr id="9" name="Text 7"/>
           <p:cNvSpPr/>
           <p:nvPr/>
         </p:nvSpPr>
         <p:spPr>
           <a:xfrm>
-            <a:off x="4471416" y="2258568"/>
-            <a:ext cx="3264408" cy="329184"/>
-          </a:xfrm>
-          <a:prstGeom prst="rect">
-            <a:avLst/>
-          </a:prstGeom>
-          <a:noFill/>
-          <a:ln/>
-        </p:spPr>
-        <p:txBody>
-          <a:bodyPr wrap="square" lIns="0" tIns="0" rIns="0" bIns="0" rtlCol="0" anchor="ctr"/>
-          <a:lstStyle/>
-          <a:p>
-            <a:pPr indent="0" marL="0">
-              <a:buNone/>
-            </a:pPr>
-            <a:r>
-              <a:rPr lang="en-US" sz="1400" b="1" dirty="0">
-                <a:solidFill>
-                  <a:srgbClr val="1B2A3A"/>
-                </a:solidFill>
-                <a:latin typeface="Calibri" pitchFamily="34" charset="0"/>
-                <a:ea typeface="Calibri" pitchFamily="34" charset="-122"/>
-                <a:cs typeface="Calibri" pitchFamily="34" charset="-120"/>
-              </a:rPr>
-              <a:t>Control — what may happen?</a:t>
-            </a:r>
-            <a:endParaRPr lang="en-US" sz="1400" dirty="0"/>
-          </a:p>
-        </p:txBody>
-      </p:sp>
-      <p:sp>
-        <p:nvSpPr>
-          <p:cNvPr id="10" name="Text 8"/>
-          <p:cNvSpPr/>
-          <p:nvPr/>
-        </p:nvSpPr>
-        <p:spPr>
-          <a:xfrm>
-            <a:off x="4471416" y="2606040"/>
-            <a:ext cx="3264408" cy="1399032"/>
+            <a:off x="4453128" y="1993392"/>
+            <a:ext cx="3310128" cy="868680"/>
           </a:xfrm>
           <a:prstGeom prst="rect">
             <a:avLst/>
@@ -2406,12 +2453,12 @@
           <a:p>
             <a:pPr indent="0" marL="0">
               <a:lnSpc>
-                <a:spcPct val="108000"/>
+                <a:spcPct val="105000"/>
               </a:lnSpc>
               <a:buNone/>
             </a:pPr>
             <a:r>
-              <a:rPr lang="en-US" sz="1100" dirty="0">
+              <a:rPr lang="en-US" sz="1050" dirty="0">
                 <a:solidFill>
                   <a:srgbClr val="545B64"/>
                 </a:solidFill>
@@ -2419,26 +2466,26 @@
                 <a:ea typeface="Calibri" pitchFamily="34" charset="-122"/>
                 <a:cs typeface="Calibri" pitchFamily="34" charset="-120"/>
               </a:rPr>
-              <a:t>The deny-by-default gateway: Cedar policies, the Guardrail, token budgets, the Kill Switch. One choke point — this is the platform's actual job.</a:t>
-            </a:r>
-            <a:endParaRPr lang="en-US" sz="1100" dirty="0"/>
-          </a:p>
-        </p:txBody>
-      </p:sp>
-      <p:sp>
-        <p:nvSpPr>
-          <p:cNvPr id="11" name="Shape 9"/>
-          <p:cNvSpPr/>
-          <p:nvPr/>
-        </p:nvSpPr>
-        <p:spPr>
-          <a:xfrm>
-            <a:off x="8065008" y="2148840"/>
-            <a:ext cx="3593592" cy="1965960"/>
+              <a:t>The governed hero-agent template: gateway wiring, audit, masking, human gate already in place.</a:t>
+            </a:r>
+            <a:endParaRPr lang="en-US" sz="1050" dirty="0"/>
+          </a:p>
+        </p:txBody>
+      </p:sp>
+      <p:sp>
+        <p:nvSpPr>
+          <p:cNvPr id="10" name="Shape 8"/>
+          <p:cNvSpPr/>
+          <p:nvPr/>
+        </p:nvSpPr>
+        <p:spPr>
+          <a:xfrm>
+            <a:off x="8065008" y="1572768"/>
+            <a:ext cx="3593592" cy="1353312"/>
           </a:xfrm>
           <a:prstGeom prst="roundRect">
             <a:avLst>
-              <a:gd name="adj" fmla="val 2791"/>
+              <a:gd name="adj" fmla="val 3378"/>
             </a:avLst>
           </a:prstGeom>
           <a:solidFill>
@@ -2454,53 +2501,53 @@
       </p:sp>
       <p:sp>
         <p:nvSpPr>
+          <p:cNvPr id="11" name="Text 9"/>
+          <p:cNvSpPr/>
+          <p:nvPr/>
+        </p:nvSpPr>
+        <p:spPr>
+          <a:xfrm>
+            <a:off x="8211312" y="1664208"/>
+            <a:ext cx="3291840" cy="310896"/>
+          </a:xfrm>
+          <a:prstGeom prst="rect">
+            <a:avLst/>
+          </a:prstGeom>
+          <a:noFill/>
+          <a:ln/>
+        </p:spPr>
+        <p:txBody>
+          <a:bodyPr wrap="square" lIns="0" tIns="0" rIns="0" bIns="0" rtlCol="0" anchor="ctr"/>
+          <a:lstStyle/>
+          <a:p>
+            <a:pPr indent="0" marL="0">
+              <a:buNone/>
+            </a:pPr>
+            <a:r>
+              <a:rPr lang="en-US" sz="1250" b="1" dirty="0">
+                <a:solidFill>
+                  <a:srgbClr val="1B2A3A"/>
+                </a:solidFill>
+                <a:latin typeface="Calibri" pitchFamily="34" charset="0"/>
+                <a:ea typeface="Calibri" pitchFamily="34" charset="-122"/>
+                <a:cs typeface="Calibri" pitchFamily="34" charset="-120"/>
+              </a:rPr>
+              <a:t>3 · Author manifest + policies</a:t>
+            </a:r>
+            <a:endParaRPr lang="en-US" sz="1250" dirty="0"/>
+          </a:p>
+        </p:txBody>
+      </p:sp>
+      <p:sp>
+        <p:nvSpPr>
           <p:cNvPr id="12" name="Text 10"/>
           <p:cNvSpPr/>
           <p:nvPr/>
         </p:nvSpPr>
         <p:spPr>
           <a:xfrm>
-            <a:off x="8229600" y="2258568"/>
-            <a:ext cx="3264408" cy="329184"/>
-          </a:xfrm>
-          <a:prstGeom prst="rect">
-            <a:avLst/>
-          </a:prstGeom>
-          <a:noFill/>
-          <a:ln/>
-        </p:spPr>
-        <p:txBody>
-          <a:bodyPr wrap="square" lIns="0" tIns="0" rIns="0" bIns="0" rtlCol="0" anchor="ctr"/>
-          <a:lstStyle/>
-          <a:p>
-            <a:pPr indent="0" marL="0">
-              <a:buNone/>
-            </a:pPr>
-            <a:r>
-              <a:rPr lang="en-US" sz="1400" b="1" dirty="0">
-                <a:solidFill>
-                  <a:srgbClr val="1B2A3A"/>
-                </a:solidFill>
-                <a:latin typeface="Calibri" pitchFamily="34" charset="0"/>
-                <a:ea typeface="Calibri" pitchFamily="34" charset="-122"/>
-                <a:cs typeface="Calibri" pitchFamily="34" charset="-120"/>
-              </a:rPr>
-              <a:t>Evidence — can you prove it?</a:t>
-            </a:r>
-            <a:endParaRPr lang="en-US" sz="1400" dirty="0"/>
-          </a:p>
-        </p:txBody>
-      </p:sp>
-      <p:sp>
-        <p:nvSpPr>
-          <p:cNvPr id="13" name="Text 11"/>
-          <p:cNvSpPr/>
-          <p:nvPr/>
-        </p:nvSpPr>
-        <p:spPr>
-          <a:xfrm>
-            <a:off x="8229600" y="2606040"/>
-            <a:ext cx="3264408" cy="1399032"/>
+            <a:off x="8211312" y="1993392"/>
+            <a:ext cx="3310128" cy="868680"/>
           </a:xfrm>
           <a:prstGeom prst="rect">
             <a:avLst/>
@@ -2514,12 +2561,12 @@
           <a:p>
             <a:pPr indent="0" marL="0">
               <a:lnSpc>
-                <a:spcPct val="108000"/>
+                <a:spcPct val="105000"/>
               </a:lnSpc>
               <a:buNone/>
             </a:pPr>
             <a:r>
-              <a:rPr lang="en-US" sz="1100" dirty="0">
+              <a:rPr lang="en-US" sz="1050" dirty="0">
                 <a:solidFill>
                   <a:srgbClr val="545B64"/>
                 </a:solidFill>
@@ -2527,33 +2574,77 @@
                 <a:ea typeface="Calibri" pitchFamily="34" charset="-122"/>
                 <a:cs typeface="Calibri" pitchFamily="34" charset="-120"/>
               </a:rPr>
-              <a:t>Append-only audit, WORM evidence bucket, CloudWatch. Write-once services that run themselves — you read them, you don't tend them.</a:t>
-            </a:r>
-            <a:endParaRPr lang="en-US" sz="1100" dirty="0"/>
-          </a:p>
-        </p:txBody>
-      </p:sp>
-      <p:sp>
-        <p:nvSpPr>
-          <p:cNvPr id="14" name="Shape 12"/>
-          <p:cNvSpPr/>
-          <p:nvPr/>
-        </p:nvSpPr>
-        <p:spPr>
-          <a:xfrm>
-            <a:off x="548640" y="4343400"/>
-            <a:ext cx="2651760" cy="1143000"/>
+              <a:t>One YAML manifest (scope, grounding, budget, evals, pack, signing) + Cedar policy files.</a:t>
+            </a:r>
+            <a:endParaRPr lang="en-US" sz="1050" dirty="0"/>
+          </a:p>
+        </p:txBody>
+      </p:sp>
+      <p:sp>
+        <p:nvSpPr>
+          <p:cNvPr id="13" name="Shape 11"/>
+          <p:cNvSpPr/>
+          <p:nvPr/>
+        </p:nvSpPr>
+        <p:spPr>
+          <a:xfrm>
+            <a:off x="548640" y="3054096"/>
+            <a:ext cx="3593592" cy="1353312"/>
           </a:xfrm>
           <a:prstGeom prst="roundRect">
             <a:avLst>
-              <a:gd name="adj" fmla="val 4800"/>
+              <a:gd name="adj" fmla="val 3378"/>
             </a:avLst>
           </a:prstGeom>
           <a:solidFill>
-            <a:srgbClr val="1B2A3A"/>
+            <a:srgbClr val="F2F3F3"/>
           </a:solidFill>
-          <a:ln/>
-        </p:spPr>
+          <a:ln w="9525">
+            <a:solidFill>
+              <a:srgbClr val="D5DBDB"/>
+            </a:solidFill>
+            <a:prstDash val="solid"/>
+          </a:ln>
+        </p:spPr>
+      </p:sp>
+      <p:sp>
+        <p:nvSpPr>
+          <p:cNvPr id="14" name="Text 12"/>
+          <p:cNvSpPr/>
+          <p:nvPr/>
+        </p:nvSpPr>
+        <p:spPr>
+          <a:xfrm>
+            <a:off x="694944" y="3145536"/>
+            <a:ext cx="3291840" cy="310896"/>
+          </a:xfrm>
+          <a:prstGeom prst="rect">
+            <a:avLst/>
+          </a:prstGeom>
+          <a:noFill/>
+          <a:ln/>
+        </p:spPr>
+        <p:txBody>
+          <a:bodyPr wrap="square" lIns="0" tIns="0" rIns="0" bIns="0" rtlCol="0" anchor="ctr"/>
+          <a:lstStyle/>
+          <a:p>
+            <a:pPr indent="0" marL="0">
+              <a:buNone/>
+            </a:pPr>
+            <a:r>
+              <a:rPr lang="en-US" sz="1250" b="1" dirty="0">
+                <a:solidFill>
+                  <a:srgbClr val="1B2A3A"/>
+                </a:solidFill>
+                <a:latin typeface="Calibri" pitchFamily="34" charset="0"/>
+                <a:ea typeface="Calibri" pitchFamily="34" charset="-122"/>
+                <a:cs typeface="Calibri" pitchFamily="34" charset="-120"/>
+              </a:rPr>
+              <a:t>4 · Build tools + evals</a:t>
+            </a:r>
+            <a:endParaRPr lang="en-US" sz="1250" dirty="0"/>
+          </a:p>
+        </p:txBody>
       </p:sp>
       <p:sp>
         <p:nvSpPr>
@@ -2563,71 +2654,35 @@
         </p:nvSpPr>
         <p:spPr>
           <a:xfrm>
-            <a:off x="548640" y="4434840"/>
-            <a:ext cx="2651760" cy="548640"/>
-          </a:xfrm>
-          <a:prstGeom prst="rect">
-            <a:avLst/>
-          </a:prstGeom>
-          <a:noFill/>
-          <a:ln/>
-        </p:spPr>
-        <p:txBody>
-          <a:bodyPr wrap="square" lIns="0" tIns="0" rIns="0" bIns="0" rtlCol="0" anchor="ctr"/>
-          <a:lstStyle/>
-          <a:p>
-            <a:pPr algn="ctr" indent="0" marL="0">
-              <a:buNone/>
-            </a:pPr>
-            <a:r>
-              <a:rPr lang="en-US" sz="2600" b="1" dirty="0">
-                <a:solidFill>
-                  <a:srgbClr val="F3B23E"/>
-                </a:solidFill>
-                <a:latin typeface="Calibri" pitchFamily="34" charset="0"/>
-                <a:ea typeface="Calibri" pitchFamily="34" charset="-122"/>
-                <a:cs typeface="Calibri" pitchFamily="34" charset="-120"/>
-              </a:rPr>
-              <a:t>9</a:t>
-            </a:r>
-            <a:endParaRPr lang="en-US" sz="2600" dirty="0"/>
-          </a:p>
-        </p:txBody>
-      </p:sp>
-      <p:sp>
-        <p:nvSpPr>
-          <p:cNvPr id="16" name="Text 14"/>
-          <p:cNvSpPr/>
-          <p:nvPr/>
-        </p:nvSpPr>
-        <p:spPr>
-          <a:xfrm>
-            <a:off x="640080" y="4983480"/>
-            <a:ext cx="2468880" cy="411480"/>
-          </a:xfrm>
-          <a:prstGeom prst="rect">
-            <a:avLst/>
-          </a:prstGeom>
-          <a:noFill/>
-          <a:ln/>
-        </p:spPr>
-        <p:txBody>
-          <a:bodyPr wrap="square" lIns="0" tIns="0" rIns="0" bIns="0" rtlCol="0" anchor="ctr"/>
-          <a:lstStyle/>
-          <a:p>
-            <a:pPr algn="ctr" indent="0" marL="0">
+            <a:off x="694944" y="3474720"/>
+            <a:ext cx="3310128" cy="868680"/>
+          </a:xfrm>
+          <a:prstGeom prst="rect">
+            <a:avLst/>
+          </a:prstGeom>
+          <a:noFill/>
+          <a:ln/>
+        </p:spPr>
+        <p:txBody>
+          <a:bodyPr wrap="square" lIns="0" tIns="0" rIns="0" bIns="0" rtlCol="0" anchor="t"/>
+          <a:lstStyle/>
+          <a:p>
+            <a:pPr indent="0" marL="0">
+              <a:lnSpc>
+                <a:spcPct val="105000"/>
+              </a:lnSpc>
               <a:buNone/>
             </a:pPr>
             <a:r>
               <a:rPr lang="en-US" sz="1050" dirty="0">
                 <a:solidFill>
-                  <a:srgbClr val="FFFFFF"/>
-                </a:solidFill>
-                <a:latin typeface="Calibri" pitchFamily="34" charset="0"/>
-                <a:ea typeface="Calibri" pitchFamily="34" charset="-122"/>
-                <a:cs typeface="Calibri" pitchFamily="34" charset="-120"/>
-              </a:rPr>
-              <a:t>managed services in the core</a:t>
+                  <a:srgbClr val="545B64"/>
+                </a:solidFill>
+                <a:latin typeface="Calibri" pitchFamily="34" charset="0"/>
+                <a:ea typeface="Calibri" pitchFamily="34" charset="-122"/>
+                <a:cs typeface="Calibri" pitchFamily="34" charset="-120"/>
+              </a:rPr>
+              <a:t>Only declared tools; consequential actions live behind the human gate. Evals with a declared pass rate.</a:t>
             </a:r>
             <a:endParaRPr lang="en-US" sz="1050" dirty="0"/>
           </a:p>
@@ -2635,25 +2690,69 @@
       </p:sp>
       <p:sp>
         <p:nvSpPr>
-          <p:cNvPr id="17" name="Shape 15"/>
-          <p:cNvSpPr/>
-          <p:nvPr/>
-        </p:nvSpPr>
-        <p:spPr>
-          <a:xfrm>
-            <a:off x="3360420" y="4343400"/>
-            <a:ext cx="2651760" cy="1143000"/>
+          <p:cNvPr id="16" name="Shape 14"/>
+          <p:cNvSpPr/>
+          <p:nvPr/>
+        </p:nvSpPr>
+        <p:spPr>
+          <a:xfrm>
+            <a:off x="4306824" y="3054096"/>
+            <a:ext cx="3593592" cy="1353312"/>
           </a:xfrm>
           <a:prstGeom prst="roundRect">
             <a:avLst>
-              <a:gd name="adj" fmla="val 4800"/>
+              <a:gd name="adj" fmla="val 3378"/>
             </a:avLst>
           </a:prstGeom>
           <a:solidFill>
-            <a:srgbClr val="1B2A3A"/>
+            <a:srgbClr val="F2F3F3"/>
           </a:solidFill>
-          <a:ln/>
-        </p:spPr>
+          <a:ln w="9525">
+            <a:solidFill>
+              <a:srgbClr val="D5DBDB"/>
+            </a:solidFill>
+            <a:prstDash val="solid"/>
+          </a:ln>
+        </p:spPr>
+      </p:sp>
+      <p:sp>
+        <p:nvSpPr>
+          <p:cNvPr id="17" name="Text 15"/>
+          <p:cNvSpPr/>
+          <p:nvPr/>
+        </p:nvSpPr>
+        <p:spPr>
+          <a:xfrm>
+            <a:off x="4453128" y="3145536"/>
+            <a:ext cx="3291840" cy="310896"/>
+          </a:xfrm>
+          <a:prstGeom prst="rect">
+            <a:avLst/>
+          </a:prstGeom>
+          <a:noFill/>
+          <a:ln/>
+        </p:spPr>
+        <p:txBody>
+          <a:bodyPr wrap="square" lIns="0" tIns="0" rIns="0" bIns="0" rtlCol="0" anchor="ctr"/>
+          <a:lstStyle/>
+          <a:p>
+            <a:pPr indent="0" marL="0">
+              <a:buNone/>
+            </a:pPr>
+            <a:r>
+              <a:rPr lang="en-US" sz="1250" b="1" dirty="0">
+                <a:solidFill>
+                  <a:srgbClr val="1B2A3A"/>
+                </a:solidFill>
+                <a:latin typeface="Calibri" pitchFamily="34" charset="0"/>
+                <a:ea typeface="Calibri" pitchFamily="34" charset="-122"/>
+                <a:cs typeface="Calibri" pitchFamily="34" charset="-120"/>
+              </a:rPr>
+              <a:t>5 · Clear the bar</a:t>
+            </a:r>
+            <a:endParaRPr lang="en-US" sz="1250" dirty="0"/>
+          </a:p>
+        </p:txBody>
       </p:sp>
       <p:sp>
         <p:nvSpPr>
@@ -2663,71 +2762,35 @@
         </p:nvSpPr>
         <p:spPr>
           <a:xfrm>
-            <a:off x="3360420" y="4434840"/>
-            <a:ext cx="2651760" cy="548640"/>
-          </a:xfrm>
-          <a:prstGeom prst="rect">
-            <a:avLst/>
-          </a:prstGeom>
-          <a:noFill/>
-          <a:ln/>
-        </p:spPr>
-        <p:txBody>
-          <a:bodyPr wrap="square" lIns="0" tIns="0" rIns="0" bIns="0" rtlCol="0" anchor="ctr"/>
-          <a:lstStyle/>
-          <a:p>
-            <a:pPr algn="ctr" indent="0" marL="0">
-              <a:buNone/>
-            </a:pPr>
-            <a:r>
-              <a:rPr lang="en-US" sz="2600" b="1" dirty="0">
-                <a:solidFill>
-                  <a:srgbClr val="F3B23E"/>
-                </a:solidFill>
-                <a:latin typeface="Calibri" pitchFamily="34" charset="0"/>
-                <a:ea typeface="Calibri" pitchFamily="34" charset="-122"/>
-                <a:cs typeface="Calibri" pitchFamily="34" charset="-120"/>
-              </a:rPr>
-              <a:t>~$1–3/mo</a:t>
-            </a:r>
-            <a:endParaRPr lang="en-US" sz="2600" dirty="0"/>
-          </a:p>
-        </p:txBody>
-      </p:sp>
-      <p:sp>
-        <p:nvSpPr>
-          <p:cNvPr id="19" name="Text 17"/>
-          <p:cNvSpPr/>
-          <p:nvPr/>
-        </p:nvSpPr>
-        <p:spPr>
-          <a:xfrm>
-            <a:off x="3451860" y="4983480"/>
-            <a:ext cx="2468880" cy="411480"/>
-          </a:xfrm>
-          <a:prstGeom prst="rect">
-            <a:avLst/>
-          </a:prstGeom>
-          <a:noFill/>
-          <a:ln/>
-        </p:spPr>
-        <p:txBody>
-          <a:bodyPr wrap="square" lIns="0" tIns="0" rIns="0" bIns="0" rtlCol="0" anchor="ctr"/>
-          <a:lstStyle/>
-          <a:p>
-            <a:pPr algn="ctr" indent="0" marL="0">
+            <a:off x="4453128" y="3474720"/>
+            <a:ext cx="3310128" cy="868680"/>
+          </a:xfrm>
+          <a:prstGeom prst="rect">
+            <a:avLst/>
+          </a:prstGeom>
+          <a:noFill/>
+          <a:ln/>
+        </p:spPr>
+        <p:txBody>
+          <a:bodyPr wrap="square" lIns="0" tIns="0" rIns="0" bIns="0" rtlCol="0" anchor="t"/>
+          <a:lstStyle/>
+          <a:p>
+            <a:pPr indent="0" marL="0">
+              <a:lnSpc>
+                <a:spcPct val="105000"/>
+              </a:lnSpc>
               <a:buNone/>
             </a:pPr>
             <a:r>
               <a:rPr lang="en-US" sz="1050" dirty="0">
                 <a:solidFill>
-                  <a:srgbClr val="FFFFFF"/>
-                </a:solidFill>
-                <a:latin typeface="Calibri" pitchFamily="34" charset="0"/>
-                <a:ea typeface="Calibri" pitchFamily="34" charset="-122"/>
-                <a:cs typeface="Calibri" pitchFamily="34" charset="-120"/>
-              </a:rPr>
-              <a:t>standing still</a:t>
+                  <a:srgbClr val="545B64"/>
+                </a:solidFill>
+                <a:latin typeface="Calibri" pitchFamily="34" charset="0"/>
+                <a:ea typeface="Calibri" pitchFamily="34" charset="-122"/>
+                <a:cs typeface="Calibri" pitchFamily="34" charset="-120"/>
+              </a:rPr>
+              <a:t>CI runs the nine gates; the manifest gets signed; the delivery gate blocks placeholders and demo retention.</a:t>
             </a:r>
             <a:endParaRPr lang="en-US" sz="1050" dirty="0"/>
           </a:p>
@@ -2735,25 +2798,69 @@
       </p:sp>
       <p:sp>
         <p:nvSpPr>
-          <p:cNvPr id="20" name="Shape 18"/>
-          <p:cNvSpPr/>
-          <p:nvPr/>
-        </p:nvSpPr>
-        <p:spPr>
-          <a:xfrm>
-            <a:off x="6172200" y="4343400"/>
-            <a:ext cx="2651760" cy="1143000"/>
+          <p:cNvPr id="19" name="Shape 17"/>
+          <p:cNvSpPr/>
+          <p:nvPr/>
+        </p:nvSpPr>
+        <p:spPr>
+          <a:xfrm>
+            <a:off x="8065008" y="3054096"/>
+            <a:ext cx="3593592" cy="1353312"/>
           </a:xfrm>
           <a:prstGeom prst="roundRect">
             <a:avLst>
-              <a:gd name="adj" fmla="val 4800"/>
+              <a:gd name="adj" fmla="val 3378"/>
             </a:avLst>
           </a:prstGeom>
           <a:solidFill>
-            <a:srgbClr val="1B2A3A"/>
+            <a:srgbClr val="F2F3F3"/>
           </a:solidFill>
-          <a:ln/>
-        </p:spPr>
+          <a:ln w="9525">
+            <a:solidFill>
+              <a:srgbClr val="D5DBDB"/>
+            </a:solidFill>
+            <a:prstDash val="solid"/>
+          </a:ln>
+        </p:spPr>
+      </p:sp>
+      <p:sp>
+        <p:nvSpPr>
+          <p:cNvPr id="20" name="Text 18"/>
+          <p:cNvSpPr/>
+          <p:nvPr/>
+        </p:nvSpPr>
+        <p:spPr>
+          <a:xfrm>
+            <a:off x="8211312" y="3145536"/>
+            <a:ext cx="3291840" cy="310896"/>
+          </a:xfrm>
+          <a:prstGeom prst="rect">
+            <a:avLst/>
+          </a:prstGeom>
+          <a:noFill/>
+          <a:ln/>
+        </p:spPr>
+        <p:txBody>
+          <a:bodyPr wrap="square" lIns="0" tIns="0" rIns="0" bIns="0" rtlCol="0" anchor="ctr"/>
+          <a:lstStyle/>
+          <a:p>
+            <a:pPr indent="0" marL="0">
+              <a:buNone/>
+            </a:pPr>
+            <a:r>
+              <a:rPr lang="en-US" sz="1250" b="1" dirty="0">
+                <a:solidFill>
+                  <a:srgbClr val="1B2A3A"/>
+                </a:solidFill>
+                <a:latin typeface="Calibri" pitchFamily="34" charset="0"/>
+                <a:ea typeface="Calibri" pitchFamily="34" charset="-122"/>
+                <a:cs typeface="Calibri" pitchFamily="34" charset="-120"/>
+              </a:rPr>
+              <a:t>6 · Deploy + drill</a:t>
+            </a:r>
+            <a:endParaRPr lang="en-US" sz="1250" dirty="0"/>
+          </a:p>
+        </p:txBody>
       </p:sp>
       <p:sp>
         <p:nvSpPr>
@@ -2763,71 +2870,35 @@
         </p:nvSpPr>
         <p:spPr>
           <a:xfrm>
-            <a:off x="6172200" y="4434840"/>
-            <a:ext cx="2651760" cy="548640"/>
-          </a:xfrm>
-          <a:prstGeom prst="rect">
-            <a:avLst/>
-          </a:prstGeom>
-          <a:noFill/>
-          <a:ln/>
-        </p:spPr>
-        <p:txBody>
-          <a:bodyPr wrap="square" lIns="0" tIns="0" rIns="0" bIns="0" rtlCol="0" anchor="ctr"/>
-          <a:lstStyle/>
-          <a:p>
-            <a:pPr algn="ctr" indent="0" marL="0">
-              <a:buNone/>
-            </a:pPr>
-            <a:r>
-              <a:rPr lang="en-US" sz="2600" b="1" dirty="0">
-                <a:solidFill>
-                  <a:srgbClr val="F3B23E"/>
-                </a:solidFill>
-                <a:latin typeface="Calibri" pitchFamily="34" charset="0"/>
-                <a:ea typeface="Calibri" pitchFamily="34" charset="-122"/>
-                <a:cs typeface="Calibri" pitchFamily="34" charset="-120"/>
-              </a:rPr>
-              <a:t>1</a:t>
-            </a:r>
-            <a:endParaRPr lang="en-US" sz="2600" dirty="0"/>
-          </a:p>
-        </p:txBody>
-      </p:sp>
-      <p:sp>
-        <p:nvSpPr>
-          <p:cNvPr id="22" name="Text 20"/>
-          <p:cNvSpPr/>
-          <p:nvPr/>
-        </p:nvSpPr>
-        <p:spPr>
-          <a:xfrm>
-            <a:off x="6263640" y="4983480"/>
-            <a:ext cx="2468880" cy="411480"/>
-          </a:xfrm>
-          <a:prstGeom prst="rect">
-            <a:avLst/>
-          </a:prstGeom>
-          <a:noFill/>
-          <a:ln/>
-        </p:spPr>
-        <p:txBody>
-          <a:bodyPr wrap="square" lIns="0" tIns="0" rIns="0" bIns="0" rtlCol="0" anchor="ctr"/>
-          <a:lstStyle/>
-          <a:p>
-            <a:pPr algn="ctr" indent="0" marL="0">
+            <a:off x="8211312" y="3474720"/>
+            <a:ext cx="3310128" cy="868680"/>
+          </a:xfrm>
+          <a:prstGeom prst="rect">
+            <a:avLst/>
+          </a:prstGeom>
+          <a:noFill/>
+          <a:ln/>
+        </p:spPr>
+        <p:txBody>
+          <a:bodyPr wrap="square" lIns="0" tIns="0" rIns="0" bIns="0" rtlCol="0" anchor="t"/>
+          <a:lstStyle/>
+          <a:p>
+            <a:pPr indent="0" marL="0">
+              <a:lnSpc>
+                <a:spcPct val="105000"/>
+              </a:lnSpc>
               <a:buNone/>
             </a:pPr>
             <a:r>
               <a:rPr lang="en-US" sz="1050" dirty="0">
                 <a:solidFill>
-                  <a:srgbClr val="FFFFFF"/>
-                </a:solidFill>
-                <a:latin typeface="Calibri" pitchFamily="34" charset="0"/>
-                <a:ea typeface="Calibri" pitchFamily="34" charset="-122"/>
-                <a:cs typeface="Calibri" pitchFamily="34" charset="-120"/>
-              </a:rPr>
-              <a:t>deploy (cdk deploy)</a:t>
+                  <a:srgbClr val="545B64"/>
+                </a:solidFill>
+                <a:latin typeface="Calibri" pitchFamily="34" charset="0"/>
+                <a:ea typeface="Calibri" pitchFamily="34" charset="-122"/>
+                <a:cs typeface="Calibri" pitchFamily="34" charset="-120"/>
+              </a:rPr>
+              <a:t>Four small stacks (cdk deploy), register with the gateway, run the canary / deny / kill-switch drills. Live.</a:t>
             </a:r>
             <a:endParaRPr lang="en-US" sz="1050" dirty="0"/>
           </a:p>
@@ -2835,25 +2906,89 @@
       </p:sp>
       <p:sp>
         <p:nvSpPr>
-          <p:cNvPr id="23" name="Shape 21"/>
-          <p:cNvSpPr/>
-          <p:nvPr/>
-        </p:nvSpPr>
-        <p:spPr>
-          <a:xfrm>
-            <a:off x="8983980" y="4343400"/>
-            <a:ext cx="2651760" cy="1143000"/>
+          <p:cNvPr id="22" name="Shape 20"/>
+          <p:cNvSpPr/>
+          <p:nvPr/>
+        </p:nvSpPr>
+        <p:spPr>
+          <a:xfrm>
+            <a:off x="548640" y="4709160"/>
+            <a:ext cx="11109960" cy="960120"/>
           </a:xfrm>
           <a:prstGeom prst="roundRect">
             <a:avLst>
-              <a:gd name="adj" fmla="val 4800"/>
+              <a:gd name="adj" fmla="val 4762"/>
             </a:avLst>
           </a:prstGeom>
           <a:solidFill>
-            <a:srgbClr val="1B2A3A"/>
+            <a:srgbClr val="F0F7F4"/>
           </a:solidFill>
-          <a:ln/>
-        </p:spPr>
+          <a:ln w="12700">
+            <a:solidFill>
+              <a:srgbClr val="0B6E4F"/>
+            </a:solidFill>
+            <a:prstDash val="solid"/>
+          </a:ln>
+        </p:spPr>
+      </p:sp>
+      <p:sp>
+        <p:nvSpPr>
+          <p:cNvPr id="23" name="Text 21"/>
+          <p:cNvSpPr/>
+          <p:nvPr/>
+        </p:nvSpPr>
+        <p:spPr>
+          <a:xfrm>
+            <a:off x="777240" y="4800600"/>
+            <a:ext cx="10698480" cy="804672"/>
+          </a:xfrm>
+          <a:prstGeom prst="rect">
+            <a:avLst/>
+          </a:prstGeom>
+          <a:noFill/>
+          <a:ln/>
+        </p:spPr>
+        <p:txBody>
+          <a:bodyPr wrap="square" lIns="0" tIns="0" rIns="0" bIns="0" rtlCol="0" anchor="ctr"/>
+          <a:lstStyle/>
+          <a:p>
+            <a:pPr indent="0" marL="0">
+              <a:lnSpc>
+                <a:spcPct val="106000"/>
+              </a:lnSpc>
+              <a:buNone/>
+            </a:pPr>
+            <a:r>
+              <a:rPr lang="en-US" sz="1200" b="1" dirty="0">
+                <a:solidFill>
+                  <a:srgbClr val="0B6E4F"/>
+                </a:solidFill>
+                <a:latin typeface="Calibri" pitchFamily="34" charset="0"/>
+                <a:ea typeface="Calibri" pitchFamily="34" charset="-122"/>
+                <a:cs typeface="Calibri" pitchFamily="34" charset="-120"/>
+              </a:rPr>
+              <a:t>What every agent inherits on day one — with zero observability code of its own:  </a:t>
+            </a:r>
+            <a:pPr indent="0" marL="0">
+              <a:lnSpc>
+                <a:spcPct val="106000"/>
+              </a:lnSpc>
+              <a:buNone/>
+            </a:pPr>
+            <a:r>
+              <a:rPr lang="en-US" sz="1200" dirty="0">
+                <a:solidFill>
+                  <a:srgbClr val="29473C"/>
+                </a:solidFill>
+                <a:latin typeface="Calibri" pitchFamily="34" charset="0"/>
+                <a:ea typeface="Calibri" pitchFamily="34" charset="-122"/>
+                <a:cs typeface="Calibri" pitchFamily="34" charset="-120"/>
+              </a:rPr>
+              <a:t>the operations dashboard, hash-chained audit trail, guardrail masking, budget alarms and chargeback, and kill-switch coverage. The agent team writes business logic; the platform does the governing.</a:t>
+            </a:r>
+            <a:endParaRPr lang="en-US" sz="1200" dirty="0"/>
+          </a:p>
+        </p:txBody>
       </p:sp>
       <p:sp>
         <p:nvSpPr>
@@ -2863,8 +2998,8 @@
         </p:nvSpPr>
         <p:spPr>
           <a:xfrm>
-            <a:off x="8983980" y="4434840"/>
-            <a:ext cx="2651760" cy="548640"/>
+            <a:off x="548640" y="5760720"/>
+            <a:ext cx="11064240" cy="365760"/>
           </a:xfrm>
           <a:prstGeom prst="rect">
             <a:avLst/>
@@ -2880,101 +3015,23 @@
               <a:buNone/>
             </a:pPr>
             <a:r>
-              <a:rPr lang="en-US" sz="2600" b="1" dirty="0">
-                <a:solidFill>
-                  <a:srgbClr val="F3B23E"/>
-                </a:solidFill>
-                <a:latin typeface="Calibri" pitchFamily="34" charset="0"/>
-                <a:ea typeface="Calibri" pitchFamily="34" charset="-122"/>
-                <a:cs typeface="Calibri" pitchFamily="34" charset="-120"/>
-              </a:rPr>
-              <a:t>~10</a:t>
-            </a:r>
-            <a:endParaRPr lang="en-US" sz="2600" dirty="0"/>
+              <a:rPr lang="en-US" sz="1200" b="1" i="1" dirty="0">
+                <a:solidFill>
+                  <a:srgbClr val="0B6E4F"/>
+                </a:solidFill>
+                <a:latin typeface="Calibri" pitchFamily="34" charset="0"/>
+                <a:ea typeface="Calibri" pitchFamily="34" charset="-122"/>
+                <a:cs typeface="Calibri" pitchFamily="34" charset="-120"/>
+              </a:rPr>
+              <a:t>1–2 weeks  ·  ~6 artifacts authored  ·  0 lines of observability code  ·  full runbook ships in the repo (AGENT-ONBOARDING-RUNBOOK.md)</a:t>
+            </a:r>
+            <a:endParaRPr lang="en-US" sz="1200" dirty="0"/>
           </a:p>
         </p:txBody>
       </p:sp>
       <p:sp>
         <p:nvSpPr>
           <p:cNvPr id="25" name="Text 23"/>
-          <p:cNvSpPr/>
-          <p:nvPr/>
-        </p:nvSpPr>
-        <p:spPr>
-          <a:xfrm>
-            <a:off x="9075420" y="4983480"/>
-            <a:ext cx="2468880" cy="411480"/>
-          </a:xfrm>
-          <a:prstGeom prst="rect">
-            <a:avLst/>
-          </a:prstGeom>
-          <a:noFill/>
-          <a:ln/>
-        </p:spPr>
-        <p:txBody>
-          <a:bodyPr wrap="square" lIns="0" tIns="0" rIns="0" bIns="0" rtlCol="0" anchor="ctr"/>
-          <a:lstStyle/>
-          <a:p>
-            <a:pPr algn="ctr" indent="0" marL="0">
-              <a:buNone/>
-            </a:pPr>
-            <a:r>
-              <a:rPr lang="en-US" sz="1050" dirty="0">
-                <a:solidFill>
-                  <a:srgbClr val="FFFFFF"/>
-                </a:solidFill>
-                <a:latin typeface="Calibri" pitchFamily="34" charset="0"/>
-                <a:ea typeface="Calibri" pitchFamily="34" charset="-122"/>
-                <a:cs typeface="Calibri" pitchFamily="34" charset="-120"/>
-              </a:rPr>
-              <a:t>decisions you actually make</a:t>
-            </a:r>
-            <a:endParaRPr lang="en-US" sz="1050" dirty="0"/>
-          </a:p>
-        </p:txBody>
-      </p:sp>
-      <p:sp>
-        <p:nvSpPr>
-          <p:cNvPr id="26" name="Text 24"/>
-          <p:cNvSpPr/>
-          <p:nvPr/>
-        </p:nvSpPr>
-        <p:spPr>
-          <a:xfrm>
-            <a:off x="548640" y="5715000"/>
-            <a:ext cx="11064240" cy="411480"/>
-          </a:xfrm>
-          <a:prstGeom prst="rect">
-            <a:avLst/>
-          </a:prstGeom>
-          <a:noFill/>
-          <a:ln/>
-        </p:spPr>
-        <p:txBody>
-          <a:bodyPr wrap="square" lIns="0" tIns="0" rIns="0" bIns="0" rtlCol="0" anchor="ctr"/>
-          <a:lstStyle/>
-          <a:p>
-            <a:pPr algn="ctr" indent="0" marL="0">
-              <a:buNone/>
-            </a:pPr>
-            <a:r>
-              <a:rPr lang="en-US" sz="1400" b="1" i="1" dirty="0">
-                <a:solidFill>
-                  <a:srgbClr val="0B6E4F"/>
-                </a:solidFill>
-                <a:latin typeface="Calibri" pitchFamily="34" charset="0"/>
-                <a:ea typeface="Calibri" pitchFamily="34" charset="-122"/>
-                <a:cs typeface="Calibri" pitchFamily="34" charset="-120"/>
-              </a:rPr>
-              <a:t>You don't operate thirty services. You answer three questions — and the stack answers back with evidence.</a:t>
-            </a:r>
-            <a:endParaRPr lang="en-US" sz="1400" dirty="0"/>
-          </a:p>
-        </p:txBody>
-      </p:sp>
-      <p:sp>
-        <p:nvSpPr>
-          <p:cNvPr id="27" name="Text 25"/>
           <p:cNvSpPr/>
           <p:nvPr/>
         </p:nvSpPr>
@@ -3013,7 +3070,7 @@
       </p:sp>
       <p:sp>
         <p:nvSpPr>
-          <p:cNvPr id="28" name="Text 26"/>
+          <p:cNvPr id="26" name="Text 24"/>
           <p:cNvSpPr/>
           <p:nvPr/>
         </p:nvSpPr>
@@ -3044,7 +3101,7 @@
                 <a:ea typeface="Calibri" pitchFamily="34" charset="-122"/>
                 <a:cs typeface="Calibri" pitchFamily="34" charset="-120"/>
               </a:rPr>
-              <a:t>10 / 12</a:t>
+              <a:t>10 / 13</a:t>
             </a:r>
             <a:endParaRPr lang="en-US" sz="900" dirty="0"/>
           </a:p>
@@ -3108,7 +3165,7 @@
                 <a:ea typeface="Calibri" pitchFamily="34" charset="-122"/>
                 <a:cs typeface="Calibri" pitchFamily="34" charset="-120"/>
               </a:rPr>
-              <a:t>08 · STRAIGHT ANSWERS</a:t>
+              <a:t>07 · COMPLEXITY, HONESTLY</a:t>
             </a:r>
             <a:endParaRPr lang="en-US" sz="1200" dirty="0"/>
           </a:p>
@@ -3147,7 +3204,7 @@
                 <a:ea typeface="Calibri" pitchFamily="34" charset="-122"/>
                 <a:cs typeface="Calibri" pitchFamily="34" charset="-120"/>
               </a:rPr>
-              <a:t>The Questions You Should Ask Us</a:t>
+              <a:t>It's Smaller Than It Looks</a:t>
             </a:r>
             <a:endParaRPr lang="en-US" sz="3000" dirty="0"/>
           </a:p>
@@ -3155,82 +3212,60 @@
       </p:sp>
       <p:sp>
         <p:nvSpPr>
-          <p:cNvPr id="4" name="Shape 2"/>
-          <p:cNvSpPr/>
-          <p:nvPr/>
-        </p:nvSpPr>
-        <p:spPr>
-          <a:xfrm>
-            <a:off x="548640" y="1600200"/>
-            <a:ext cx="3291840" cy="1005840"/>
+          <p:cNvPr id="4" name="Text 2"/>
+          <p:cNvSpPr/>
+          <p:nvPr/>
+        </p:nvSpPr>
+        <p:spPr>
+          <a:xfrm>
+            <a:off x="548640" y="1481328"/>
+            <a:ext cx="11064240" cy="502920"/>
+          </a:xfrm>
+          <a:prstGeom prst="rect">
+            <a:avLst/>
+          </a:prstGeom>
+          <a:noFill/>
+          <a:ln/>
+        </p:spPr>
+        <p:txBody>
+          <a:bodyPr wrap="square" lIns="0" tIns="0" rIns="0" bIns="0" rtlCol="0" anchor="ctr"/>
+          <a:lstStyle/>
+          <a:p>
+            <a:pPr indent="0" marL="0">
+              <a:lnSpc>
+                <a:spcPct val="110000"/>
+              </a:lnSpc>
+              <a:buNone/>
+            </a:pPr>
+            <a:r>
+              <a:rPr lang="en-US" sz="1350" dirty="0">
+                <a:solidFill>
+                  <a:srgbClr val="545B64"/>
+                </a:solidFill>
+                <a:latin typeface="Calibri" pitchFamily="34" charset="0"/>
+                <a:ea typeface="Calibri" pitchFamily="34" charset="-122"/>
+                <a:cs typeface="Calibri" pitchFamily="34" charset="-120"/>
+              </a:rPr>
+              <a:t>The service map is real — but it is not what you operate. Operationally this is three planes answering the three questions your CISO already asks, deployed as one stack.</a:t>
+            </a:r>
+            <a:endParaRPr lang="en-US" sz="1350" dirty="0"/>
+          </a:p>
+        </p:txBody>
+      </p:sp>
+      <p:sp>
+        <p:nvSpPr>
+          <p:cNvPr id="5" name="Shape 3"/>
+          <p:cNvSpPr/>
+          <p:nvPr/>
+        </p:nvSpPr>
+        <p:spPr>
+          <a:xfrm>
+            <a:off x="548640" y="2148840"/>
+            <a:ext cx="3593592" cy="1965960"/>
           </a:xfrm>
           <a:prstGeom prst="roundRect">
             <a:avLst>
-              <a:gd name="adj" fmla="val 4545"/>
-            </a:avLst>
-          </a:prstGeom>
-          <a:solidFill>
-            <a:srgbClr val="1B2A3A"/>
-          </a:solidFill>
-          <a:ln/>
-        </p:spPr>
-      </p:sp>
-      <p:sp>
-        <p:nvSpPr>
-          <p:cNvPr id="5" name="Text 3"/>
-          <p:cNvSpPr/>
-          <p:nvPr/>
-        </p:nvSpPr>
-        <p:spPr>
-          <a:xfrm>
-            <a:off x="713232" y="1600200"/>
-            <a:ext cx="2971800" cy="1005840"/>
-          </a:xfrm>
-          <a:prstGeom prst="rect">
-            <a:avLst/>
-          </a:prstGeom>
-          <a:noFill/>
-          <a:ln/>
-        </p:spPr>
-        <p:txBody>
-          <a:bodyPr wrap="square" lIns="0" tIns="0" rIns="0" bIns="0" rtlCol="0" anchor="ctr"/>
-          <a:lstStyle/>
-          <a:p>
-            <a:pPr indent="0" marL="0">
-              <a:lnSpc>
-                <a:spcPct val="105000"/>
-              </a:lnSpc>
-              <a:buNone/>
-            </a:pPr>
-            <a:r>
-              <a:rPr lang="en-US" sz="1200" b="1" dirty="0">
-                <a:solidFill>
-                  <a:srgbClr val="FFFFFF"/>
-                </a:solidFill>
-                <a:latin typeface="Calibri" pitchFamily="34" charset="0"/>
-                <a:ea typeface="Calibri" pitchFamily="34" charset="-122"/>
-                <a:cs typeface="Calibri" pitchFamily="34" charset="-120"/>
-              </a:rPr>
-              <a:t>“Is this an official product?”</a:t>
-            </a:r>
-            <a:endParaRPr lang="en-US" sz="1200" dirty="0"/>
-          </a:p>
-        </p:txBody>
-      </p:sp>
-      <p:sp>
-        <p:nvSpPr>
-          <p:cNvPr id="6" name="Shape 4"/>
-          <p:cNvSpPr/>
-          <p:nvPr/>
-        </p:nvSpPr>
-        <p:spPr>
-          <a:xfrm>
-            <a:off x="3931920" y="1600200"/>
-            <a:ext cx="7726680" cy="1005840"/>
-          </a:xfrm>
-          <a:prstGeom prst="roundRect">
-            <a:avLst>
-              <a:gd name="adj" fmla="val 4545"/>
+              <a:gd name="adj" fmla="val 2791"/>
             </a:avLst>
           </a:prstGeom>
           <a:solidFill>
@@ -3246,33 +3281,72 @@
       </p:sp>
       <p:sp>
         <p:nvSpPr>
+          <p:cNvPr id="6" name="Text 4"/>
+          <p:cNvSpPr/>
+          <p:nvPr/>
+        </p:nvSpPr>
+        <p:spPr>
+          <a:xfrm>
+            <a:off x="713232" y="2258568"/>
+            <a:ext cx="3264408" cy="329184"/>
+          </a:xfrm>
+          <a:prstGeom prst="rect">
+            <a:avLst/>
+          </a:prstGeom>
+          <a:noFill/>
+          <a:ln/>
+        </p:spPr>
+        <p:txBody>
+          <a:bodyPr wrap="square" lIns="0" tIns="0" rIns="0" bIns="0" rtlCol="0" anchor="ctr"/>
+          <a:lstStyle/>
+          <a:p>
+            <a:pPr indent="0" marL="0">
+              <a:buNone/>
+            </a:pPr>
+            <a:r>
+              <a:rPr lang="en-US" sz="1400" b="1" dirty="0">
+                <a:solidFill>
+                  <a:srgbClr val="1B2A3A"/>
+                </a:solidFill>
+                <a:latin typeface="Calibri" pitchFamily="34" charset="0"/>
+                <a:ea typeface="Calibri" pitchFamily="34" charset="-122"/>
+                <a:cs typeface="Calibri" pitchFamily="34" charset="-120"/>
+              </a:rPr>
+              <a:t>Identity — who is acting?</a:t>
+            </a:r>
+            <a:endParaRPr lang="en-US" sz="1400" dirty="0"/>
+          </a:p>
+        </p:txBody>
+      </p:sp>
+      <p:sp>
+        <p:nvSpPr>
           <p:cNvPr id="7" name="Text 5"/>
           <p:cNvSpPr/>
           <p:nvPr/>
         </p:nvSpPr>
         <p:spPr>
           <a:xfrm>
-            <a:off x="4096512" y="1655064"/>
-            <a:ext cx="7406640" cy="914400"/>
-          </a:xfrm>
-          <a:prstGeom prst="rect">
-            <a:avLst/>
-          </a:prstGeom>
-          <a:noFill/>
-          <a:ln/>
-        </p:spPr>
-        <p:txBody>
-          <a:bodyPr wrap="square" lIns="0" tIns="0" rIns="0" bIns="0" rtlCol="0" anchor="ctr"/>
+            <a:off x="713232" y="2606040"/>
+            <a:ext cx="3264408" cy="1399032"/>
+          </a:xfrm>
+          <a:prstGeom prst="rect">
+            <a:avLst/>
+          </a:prstGeom>
+          <a:noFill/>
+          <a:ln/>
+        </p:spPr>
+        <p:txBody>
+          <a:bodyPr wrap="square" lIns="0" tIns="0" rIns="0" bIns="0" rtlCol="0" anchor="t"/>
           <a:lstStyle/>
           <a:p>
             <a:pPr indent="0" marL="0">
               <a:lnSpc>
-                <a:spcPct val="105000"/>
+                <a:spcPct val="108000"/>
               </a:lnSpc>
               <a:buNone/>
             </a:pPr>
             <a:r>
-              <a:rPr lang="en-US" sz="1050" dirty="0">
+              <a:rPr lang="en-US" sz="1100" dirty="0">
                 <a:solidFill>
                   <a:srgbClr val="545B64"/>
                 </a:solidFill>
@@ -3280,9 +3354,9 @@
                 <a:ea typeface="Calibri" pitchFamily="34" charset="-122"/>
                 <a:cs typeface="Calibri" pitchFamily="34" charset="-120"/>
               </a:rPr>
-              <a:t>No — and the repo says so in writing (NOT-CLAIMS). It's an open reference architecture built on AWS services: you fork it, review every line, and own what you run. No lock-in, no license fee, no black box.</a:t>
-            </a:r>
-            <a:endParaRPr lang="en-US" sz="1050" dirty="0"/>
+              <a:t>Cognito federated to YOUR IdP, IAM, verified JWTs. Services your account already runs — zero new operational surface.</a:t>
+            </a:r>
+            <a:endParaRPr lang="en-US" sz="1100" dirty="0"/>
           </a:p>
         </p:txBody>
       </p:sp>
@@ -3294,76 +3368,12 @@
         </p:nvSpPr>
         <p:spPr>
           <a:xfrm>
-            <a:off x="548640" y="2734056"/>
-            <a:ext cx="3291840" cy="1005840"/>
+            <a:off x="4306824" y="2148840"/>
+            <a:ext cx="3593592" cy="1965960"/>
           </a:xfrm>
           <a:prstGeom prst="roundRect">
             <a:avLst>
-              <a:gd name="adj" fmla="val 4545"/>
-            </a:avLst>
-          </a:prstGeom>
-          <a:solidFill>
-            <a:srgbClr val="1B2A3A"/>
-          </a:solidFill>
-          <a:ln/>
-        </p:spPr>
-      </p:sp>
-      <p:sp>
-        <p:nvSpPr>
-          <p:cNvPr id="9" name="Text 7"/>
-          <p:cNvSpPr/>
-          <p:nvPr/>
-        </p:nvSpPr>
-        <p:spPr>
-          <a:xfrm>
-            <a:off x="713232" y="2734056"/>
-            <a:ext cx="2971800" cy="1005840"/>
-          </a:xfrm>
-          <a:prstGeom prst="rect">
-            <a:avLst/>
-          </a:prstGeom>
-          <a:noFill/>
-          <a:ln/>
-        </p:spPr>
-        <p:txBody>
-          <a:bodyPr wrap="square" lIns="0" tIns="0" rIns="0" bIns="0" rtlCol="0" anchor="ctr"/>
-          <a:lstStyle/>
-          <a:p>
-            <a:pPr indent="0" marL="0">
-              <a:lnSpc>
-                <a:spcPct val="105000"/>
-              </a:lnSpc>
-              <a:buNone/>
-            </a:pPr>
-            <a:r>
-              <a:rPr lang="en-US" sz="1200" b="1" dirty="0">
-                <a:solidFill>
-                  <a:srgbClr val="FFFFFF"/>
-                </a:solidFill>
-                <a:latin typeface="Calibri" pitchFamily="34" charset="0"/>
-                <a:ea typeface="Calibri" pitchFamily="34" charset="-122"/>
-                <a:cs typeface="Calibri" pitchFamily="34" charset="-120"/>
-              </a:rPr>
-              <a:t>“We already have IAM / a WAF / audit logs.”</a:t>
-            </a:r>
-            <a:endParaRPr lang="en-US" sz="1200" dirty="0"/>
-          </a:p>
-        </p:txBody>
-      </p:sp>
-      <p:sp>
-        <p:nvSpPr>
-          <p:cNvPr id="10" name="Shape 8"/>
-          <p:cNvSpPr/>
-          <p:nvPr/>
-        </p:nvSpPr>
-        <p:spPr>
-          <a:xfrm>
-            <a:off x="3931920" y="2734056"/>
-            <a:ext cx="7726680" cy="1005840"/>
-          </a:xfrm>
-          <a:prstGeom prst="roundRect">
-            <a:avLst>
-              <a:gd name="adj" fmla="val 4545"/>
+              <a:gd name="adj" fmla="val 2791"/>
             </a:avLst>
           </a:prstGeom>
           <a:solidFill>
@@ -3379,33 +3389,72 @@
       </p:sp>
       <p:sp>
         <p:nvSpPr>
-          <p:cNvPr id="11" name="Text 9"/>
-          <p:cNvSpPr/>
-          <p:nvPr/>
-        </p:nvSpPr>
-        <p:spPr>
-          <a:xfrm>
-            <a:off x="4096512" y="2788920"/>
-            <a:ext cx="7406640" cy="914400"/>
-          </a:xfrm>
-          <a:prstGeom prst="rect">
-            <a:avLst/>
-          </a:prstGeom>
-          <a:noFill/>
-          <a:ln/>
-        </p:spPr>
-        <p:txBody>
-          <a:bodyPr wrap="square" lIns="0" tIns="0" rIns="0" bIns="0" rtlCol="0" anchor="ctr"/>
+          <p:cNvPr id="9" name="Text 7"/>
+          <p:cNvSpPr/>
+          <p:nvPr/>
+        </p:nvSpPr>
+        <p:spPr>
+          <a:xfrm>
+            <a:off x="4471416" y="2258568"/>
+            <a:ext cx="3264408" cy="329184"/>
+          </a:xfrm>
+          <a:prstGeom prst="rect">
+            <a:avLst/>
+          </a:prstGeom>
+          <a:noFill/>
+          <a:ln/>
+        </p:spPr>
+        <p:txBody>
+          <a:bodyPr wrap="square" lIns="0" tIns="0" rIns="0" bIns="0" rtlCol="0" anchor="ctr"/>
+          <a:lstStyle/>
+          <a:p>
+            <a:pPr indent="0" marL="0">
+              <a:buNone/>
+            </a:pPr>
+            <a:r>
+              <a:rPr lang="en-US" sz="1400" b="1" dirty="0">
+                <a:solidFill>
+                  <a:srgbClr val="1B2A3A"/>
+                </a:solidFill>
+                <a:latin typeface="Calibri" pitchFamily="34" charset="0"/>
+                <a:ea typeface="Calibri" pitchFamily="34" charset="-122"/>
+                <a:cs typeface="Calibri" pitchFamily="34" charset="-120"/>
+              </a:rPr>
+              <a:t>Control — what may happen?</a:t>
+            </a:r>
+            <a:endParaRPr lang="en-US" sz="1400" dirty="0"/>
+          </a:p>
+        </p:txBody>
+      </p:sp>
+      <p:sp>
+        <p:nvSpPr>
+          <p:cNvPr id="10" name="Text 8"/>
+          <p:cNvSpPr/>
+          <p:nvPr/>
+        </p:nvSpPr>
+        <p:spPr>
+          <a:xfrm>
+            <a:off x="4471416" y="2606040"/>
+            <a:ext cx="3264408" cy="1399032"/>
+          </a:xfrm>
+          <a:prstGeom prst="rect">
+            <a:avLst/>
+          </a:prstGeom>
+          <a:noFill/>
+          <a:ln/>
+        </p:spPr>
+        <p:txBody>
+          <a:bodyPr wrap="square" lIns="0" tIns="0" rIns="0" bIns="0" rtlCol="0" anchor="t"/>
           <a:lstStyle/>
           <a:p>
             <a:pPr indent="0" marL="0">
               <a:lnSpc>
-                <a:spcPct val="105000"/>
+                <a:spcPct val="108000"/>
               </a:lnSpc>
               <a:buNone/>
             </a:pPr>
             <a:r>
-              <a:rPr lang="en-US" sz="1050" dirty="0">
+              <a:rPr lang="en-US" sz="1100" dirty="0">
                 <a:solidFill>
                   <a:srgbClr val="545B64"/>
                 </a:solidFill>
@@ -3413,90 +3462,26 @@
                 <a:ea typeface="Calibri" pitchFamily="34" charset="-122"/>
                 <a:cs typeface="Calibri" pitchFamily="34" charset="-120"/>
               </a:rPr>
-              <a:t>Keep them — the platform composes them. What you're missing is the agent-specific layer: agent∩human intersection, consequential-action gates, prompt-boundary masking, per-agent budgets, and one audit spine across departments.</a:t>
-            </a:r>
-            <a:endParaRPr lang="en-US" sz="1050" dirty="0"/>
-          </a:p>
-        </p:txBody>
-      </p:sp>
-      <p:sp>
-        <p:nvSpPr>
-          <p:cNvPr id="12" name="Shape 10"/>
-          <p:cNvSpPr/>
-          <p:nvPr/>
-        </p:nvSpPr>
-        <p:spPr>
-          <a:xfrm>
-            <a:off x="548640" y="3867912"/>
-            <a:ext cx="3291840" cy="1005840"/>
+              <a:t>The deny-by-default gateway: Cedar policies, the Guardrail, token budgets, the Kill Switch. One choke point — this is the platform's actual job.</a:t>
+            </a:r>
+            <a:endParaRPr lang="en-US" sz="1100" dirty="0"/>
+          </a:p>
+        </p:txBody>
+      </p:sp>
+      <p:sp>
+        <p:nvSpPr>
+          <p:cNvPr id="11" name="Shape 9"/>
+          <p:cNvSpPr/>
+          <p:nvPr/>
+        </p:nvSpPr>
+        <p:spPr>
+          <a:xfrm>
+            <a:off x="8065008" y="2148840"/>
+            <a:ext cx="3593592" cy="1965960"/>
           </a:xfrm>
           <a:prstGeom prst="roundRect">
             <a:avLst>
-              <a:gd name="adj" fmla="val 4545"/>
-            </a:avLst>
-          </a:prstGeom>
-          <a:solidFill>
-            <a:srgbClr val="1B2A3A"/>
-          </a:solidFill>
-          <a:ln/>
-        </p:spPr>
-      </p:sp>
-      <p:sp>
-        <p:nvSpPr>
-          <p:cNvPr id="13" name="Text 11"/>
-          <p:cNvSpPr/>
-          <p:nvPr/>
-        </p:nvSpPr>
-        <p:spPr>
-          <a:xfrm>
-            <a:off x="713232" y="3867912"/>
-            <a:ext cx="2971800" cy="1005840"/>
-          </a:xfrm>
-          <a:prstGeom prst="rect">
-            <a:avLst/>
-          </a:prstGeom>
-          <a:noFill/>
-          <a:ln/>
-        </p:spPr>
-        <p:txBody>
-          <a:bodyPr wrap="square" lIns="0" tIns="0" rIns="0" bIns="0" rtlCol="0" anchor="ctr"/>
-          <a:lstStyle/>
-          <a:p>
-            <a:pPr indent="0" marL="0">
-              <a:lnSpc>
-                <a:spcPct val="105000"/>
-              </a:lnSpc>
-              <a:buNone/>
-            </a:pPr>
-            <a:r>
-              <a:rPr lang="en-US" sz="1200" b="1" dirty="0">
-                <a:solidFill>
-                  <a:srgbClr val="FFFFFF"/>
-                </a:solidFill>
-                <a:latin typeface="Calibri" pitchFamily="34" charset="0"/>
-                <a:ea typeface="Calibri" pitchFamily="34" charset="-122"/>
-                <a:cs typeface="Calibri" pitchFamily="34" charset="-120"/>
-              </a:rPr>
-              <a:t>“Can our existing agents fit?”</a:t>
-            </a:r>
-            <a:endParaRPr lang="en-US" sz="1200" dirty="0"/>
-          </a:p>
-        </p:txBody>
-      </p:sp>
-      <p:sp>
-        <p:nvSpPr>
-          <p:cNvPr id="14" name="Shape 12"/>
-          <p:cNvSpPr/>
-          <p:nvPr/>
-        </p:nvSpPr>
-        <p:spPr>
-          <a:xfrm>
-            <a:off x="3931920" y="3867912"/>
-            <a:ext cx="7726680" cy="1005840"/>
-          </a:xfrm>
-          <a:prstGeom prst="roundRect">
-            <a:avLst>
-              <a:gd name="adj" fmla="val 4545"/>
+              <a:gd name="adj" fmla="val 2791"/>
             </a:avLst>
           </a:prstGeom>
           <a:solidFill>
@@ -3512,33 +3497,72 @@
       </p:sp>
       <p:sp>
         <p:nvSpPr>
-          <p:cNvPr id="15" name="Text 13"/>
-          <p:cNvSpPr/>
-          <p:nvPr/>
-        </p:nvSpPr>
-        <p:spPr>
-          <a:xfrm>
-            <a:off x="4096512" y="3922776"/>
-            <a:ext cx="7406640" cy="914400"/>
-          </a:xfrm>
-          <a:prstGeom prst="rect">
-            <a:avLst/>
-          </a:prstGeom>
-          <a:noFill/>
-          <a:ln/>
-        </p:spPr>
-        <p:txBody>
-          <a:bodyPr wrap="square" lIns="0" tIns="0" rIns="0" bIns="0" rtlCol="0" anchor="ctr"/>
+          <p:cNvPr id="12" name="Text 10"/>
+          <p:cNvSpPr/>
+          <p:nvPr/>
+        </p:nvSpPr>
+        <p:spPr>
+          <a:xfrm>
+            <a:off x="8229600" y="2258568"/>
+            <a:ext cx="3264408" cy="329184"/>
+          </a:xfrm>
+          <a:prstGeom prst="rect">
+            <a:avLst/>
+          </a:prstGeom>
+          <a:noFill/>
+          <a:ln/>
+        </p:spPr>
+        <p:txBody>
+          <a:bodyPr wrap="square" lIns="0" tIns="0" rIns="0" bIns="0" rtlCol="0" anchor="ctr"/>
+          <a:lstStyle/>
+          <a:p>
+            <a:pPr indent="0" marL="0">
+              <a:buNone/>
+            </a:pPr>
+            <a:r>
+              <a:rPr lang="en-US" sz="1400" b="1" dirty="0">
+                <a:solidFill>
+                  <a:srgbClr val="1B2A3A"/>
+                </a:solidFill>
+                <a:latin typeface="Calibri" pitchFamily="34" charset="0"/>
+                <a:ea typeface="Calibri" pitchFamily="34" charset="-122"/>
+                <a:cs typeface="Calibri" pitchFamily="34" charset="-120"/>
+              </a:rPr>
+              <a:t>Evidence — can you prove it?</a:t>
+            </a:r>
+            <a:endParaRPr lang="en-US" sz="1400" dirty="0"/>
+          </a:p>
+        </p:txBody>
+      </p:sp>
+      <p:sp>
+        <p:nvSpPr>
+          <p:cNvPr id="13" name="Text 11"/>
+          <p:cNvSpPr/>
+          <p:nvPr/>
+        </p:nvSpPr>
+        <p:spPr>
+          <a:xfrm>
+            <a:off x="8229600" y="2606040"/>
+            <a:ext cx="3264408" cy="1399032"/>
+          </a:xfrm>
+          <a:prstGeom prst="rect">
+            <a:avLst/>
+          </a:prstGeom>
+          <a:noFill/>
+          <a:ln/>
+        </p:spPr>
+        <p:txBody>
+          <a:bodyPr wrap="square" lIns="0" tIns="0" rIns="0" bIns="0" rtlCol="0" anchor="t"/>
           <a:lstStyle/>
           <a:p>
             <a:pPr indent="0" marL="0">
               <a:lnSpc>
-                <a:spcPct val="105000"/>
+                <a:spcPct val="108000"/>
               </a:lnSpc>
               <a:buNone/>
             </a:pPr>
             <a:r>
-              <a:rPr lang="en-US" sz="1050" dirty="0">
+              <a:rPr lang="en-US" sz="1100" dirty="0">
                 <a:solidFill>
                   <a:srgbClr val="545B64"/>
                 </a:solidFill>
@@ -3546,26 +3570,26 @@
                 <a:ea typeface="Calibri" pitchFamily="34" charset="-122"/>
                 <a:cs typeface="Calibri" pitchFamily="34" charset="-120"/>
               </a:rPr>
-              <a:t>If they can declare a manifest and clear the nine gates, yes. The bar is the retrofit checklist — most agents fail on scope declaration and the human gate first, and both are fixable.</a:t>
-            </a:r>
-            <a:endParaRPr lang="en-US" sz="1050" dirty="0"/>
-          </a:p>
-        </p:txBody>
-      </p:sp>
-      <p:sp>
-        <p:nvSpPr>
-          <p:cNvPr id="16" name="Shape 14"/>
-          <p:cNvSpPr/>
-          <p:nvPr/>
-        </p:nvSpPr>
-        <p:spPr>
-          <a:xfrm>
-            <a:off x="548640" y="5001768"/>
-            <a:ext cx="3291840" cy="1005840"/>
+              <a:t>Append-only audit, WORM evidence bucket, CloudWatch. Write-once services that run themselves — you read them, you don't tend them.</a:t>
+            </a:r>
+            <a:endParaRPr lang="en-US" sz="1100" dirty="0"/>
+          </a:p>
+        </p:txBody>
+      </p:sp>
+      <p:sp>
+        <p:nvSpPr>
+          <p:cNvPr id="14" name="Shape 12"/>
+          <p:cNvSpPr/>
+          <p:nvPr/>
+        </p:nvSpPr>
+        <p:spPr>
+          <a:xfrm>
+            <a:off x="548640" y="4343400"/>
+            <a:ext cx="2651760" cy="1143000"/>
           </a:xfrm>
           <a:prstGeom prst="roundRect">
             <a:avLst>
-              <a:gd name="adj" fmla="val 4545"/>
+              <a:gd name="adj" fmla="val 4800"/>
             </a:avLst>
           </a:prstGeom>
           <a:solidFill>
@@ -3576,33 +3600,69 @@
       </p:sp>
       <p:sp>
         <p:nvSpPr>
-          <p:cNvPr id="17" name="Text 15"/>
-          <p:cNvSpPr/>
-          <p:nvPr/>
-        </p:nvSpPr>
-        <p:spPr>
-          <a:xfrm>
-            <a:off x="713232" y="5001768"/>
-            <a:ext cx="2971800" cy="1005840"/>
-          </a:xfrm>
-          <a:prstGeom prst="rect">
-            <a:avLst/>
-          </a:prstGeom>
-          <a:noFill/>
-          <a:ln/>
-        </p:spPr>
-        <p:txBody>
-          <a:bodyPr wrap="square" lIns="0" tIns="0" rIns="0" bIns="0" rtlCol="0" anchor="ctr"/>
-          <a:lstStyle/>
-          <a:p>
-            <a:pPr indent="0" marL="0">
-              <a:lnSpc>
-                <a:spcPct val="105000"/>
-              </a:lnSpc>
-              <a:buNone/>
-            </a:pPr>
-            <a:r>
-              <a:rPr lang="en-US" sz="1200" b="1" dirty="0">
+          <p:cNvPr id="15" name="Text 13"/>
+          <p:cNvSpPr/>
+          <p:nvPr/>
+        </p:nvSpPr>
+        <p:spPr>
+          <a:xfrm>
+            <a:off x="548640" y="4434840"/>
+            <a:ext cx="2651760" cy="548640"/>
+          </a:xfrm>
+          <a:prstGeom prst="rect">
+            <a:avLst/>
+          </a:prstGeom>
+          <a:noFill/>
+          <a:ln/>
+        </p:spPr>
+        <p:txBody>
+          <a:bodyPr wrap="square" lIns="0" tIns="0" rIns="0" bIns="0" rtlCol="0" anchor="ctr"/>
+          <a:lstStyle/>
+          <a:p>
+            <a:pPr algn="ctr" indent="0" marL="0">
+              <a:buNone/>
+            </a:pPr>
+            <a:r>
+              <a:rPr lang="en-US" sz="2600" b="1" dirty="0">
+                <a:solidFill>
+                  <a:srgbClr val="F3B23E"/>
+                </a:solidFill>
+                <a:latin typeface="Calibri" pitchFamily="34" charset="0"/>
+                <a:ea typeface="Calibri" pitchFamily="34" charset="-122"/>
+                <a:cs typeface="Calibri" pitchFamily="34" charset="-120"/>
+              </a:rPr>
+              <a:t>9</a:t>
+            </a:r>
+            <a:endParaRPr lang="en-US" sz="2600" dirty="0"/>
+          </a:p>
+        </p:txBody>
+      </p:sp>
+      <p:sp>
+        <p:nvSpPr>
+          <p:cNvPr id="16" name="Text 14"/>
+          <p:cNvSpPr/>
+          <p:nvPr/>
+        </p:nvSpPr>
+        <p:spPr>
+          <a:xfrm>
+            <a:off x="640080" y="4983480"/>
+            <a:ext cx="2468880" cy="411480"/>
+          </a:xfrm>
+          <a:prstGeom prst="rect">
+            <a:avLst/>
+          </a:prstGeom>
+          <a:noFill/>
+          <a:ln/>
+        </p:spPr>
+        <p:txBody>
+          <a:bodyPr wrap="square" lIns="0" tIns="0" rIns="0" bIns="0" rtlCol="0" anchor="ctr"/>
+          <a:lstStyle/>
+          <a:p>
+            <a:pPr algn="ctr" indent="0" marL="0">
+              <a:buNone/>
+            </a:pPr>
+            <a:r>
+              <a:rPr lang="en-US" sz="1050" dirty="0">
                 <a:solidFill>
                   <a:srgbClr val="FFFFFF"/>
                 </a:solidFill>
@@ -3610,38 +3670,72 @@
                 <a:ea typeface="Calibri" pitchFamily="34" charset="-122"/>
                 <a:cs typeface="Calibri" pitchFamily="34" charset="-120"/>
               </a:rPr>
-              <a:t>“What about GovCloud / our BAA?”</a:t>
-            </a:r>
-            <a:endParaRPr lang="en-US" sz="1200" dirty="0"/>
-          </a:p>
-        </p:txBody>
-      </p:sp>
-      <p:sp>
-        <p:nvSpPr>
-          <p:cNvPr id="18" name="Shape 16"/>
-          <p:cNvSpPr/>
-          <p:nvPr/>
-        </p:nvSpPr>
-        <p:spPr>
-          <a:xfrm>
-            <a:off x="3931920" y="5001768"/>
-            <a:ext cx="7726680" cy="1005840"/>
+              <a:t>managed services in the core</a:t>
+            </a:r>
+            <a:endParaRPr lang="en-US" sz="1050" dirty="0"/>
+          </a:p>
+        </p:txBody>
+      </p:sp>
+      <p:sp>
+        <p:nvSpPr>
+          <p:cNvPr id="17" name="Shape 15"/>
+          <p:cNvSpPr/>
+          <p:nvPr/>
+        </p:nvSpPr>
+        <p:spPr>
+          <a:xfrm>
+            <a:off x="3360420" y="4343400"/>
+            <a:ext cx="2651760" cy="1143000"/>
           </a:xfrm>
           <a:prstGeom prst="roundRect">
             <a:avLst>
-              <a:gd name="adj" fmla="val 4545"/>
+              <a:gd name="adj" fmla="val 4800"/>
             </a:avLst>
           </a:prstGeom>
           <a:solidFill>
-            <a:srgbClr val="F2F3F3"/>
+            <a:srgbClr val="1B2A3A"/>
           </a:solidFill>
-          <a:ln w="9525">
-            <a:solidFill>
-              <a:srgbClr val="D5DBDB"/>
-            </a:solidFill>
-            <a:prstDash val="solid"/>
-          </a:ln>
-        </p:spPr>
+          <a:ln/>
+        </p:spPr>
+      </p:sp>
+      <p:sp>
+        <p:nvSpPr>
+          <p:cNvPr id="18" name="Text 16"/>
+          <p:cNvSpPr/>
+          <p:nvPr/>
+        </p:nvSpPr>
+        <p:spPr>
+          <a:xfrm>
+            <a:off x="3360420" y="4434840"/>
+            <a:ext cx="2651760" cy="548640"/>
+          </a:xfrm>
+          <a:prstGeom prst="rect">
+            <a:avLst/>
+          </a:prstGeom>
+          <a:noFill/>
+          <a:ln/>
+        </p:spPr>
+        <p:txBody>
+          <a:bodyPr wrap="square" lIns="0" tIns="0" rIns="0" bIns="0" rtlCol="0" anchor="ctr"/>
+          <a:lstStyle/>
+          <a:p>
+            <a:pPr algn="ctr" indent="0" marL="0">
+              <a:buNone/>
+            </a:pPr>
+            <a:r>
+              <a:rPr lang="en-US" sz="2600" b="1" dirty="0">
+                <a:solidFill>
+                  <a:srgbClr val="F3B23E"/>
+                </a:solidFill>
+                <a:latin typeface="Calibri" pitchFamily="34" charset="0"/>
+                <a:ea typeface="Calibri" pitchFamily="34" charset="-122"/>
+                <a:cs typeface="Calibri" pitchFamily="34" charset="-120"/>
+              </a:rPr>
+              <a:t>~$1–3/mo</a:t>
+            </a:r>
+            <a:endParaRPr lang="en-US" sz="2600" dirty="0"/>
+          </a:p>
+        </p:txBody>
       </p:sp>
       <p:sp>
         <p:nvSpPr>
@@ -3651,35 +3745,32 @@
         </p:nvSpPr>
         <p:spPr>
           <a:xfrm>
-            <a:off x="4096512" y="5056632"/>
-            <a:ext cx="7406640" cy="914400"/>
-          </a:xfrm>
-          <a:prstGeom prst="rect">
-            <a:avLst/>
-          </a:prstGeom>
-          <a:noFill/>
-          <a:ln/>
-        </p:spPr>
-        <p:txBody>
-          <a:bodyPr wrap="square" lIns="0" tIns="0" rIns="0" bIns="0" rtlCol="0" anchor="ctr"/>
-          <a:lstStyle/>
-          <a:p>
-            <a:pPr indent="0" marL="0">
-              <a:lnSpc>
-                <a:spcPct val="105000"/>
-              </a:lnSpc>
+            <a:off x="3451860" y="4983480"/>
+            <a:ext cx="2468880" cy="411480"/>
+          </a:xfrm>
+          <a:prstGeom prst="rect">
+            <a:avLst/>
+          </a:prstGeom>
+          <a:noFill/>
+          <a:ln/>
+        </p:spPr>
+        <p:txBody>
+          <a:bodyPr wrap="square" lIns="0" tIns="0" rIns="0" bIns="0" rtlCol="0" anchor="ctr"/>
+          <a:lstStyle/>
+          <a:p>
+            <a:pPr algn="ctr" indent="0" marL="0">
               <a:buNone/>
             </a:pPr>
             <a:r>
               <a:rPr lang="en-US" sz="1050" dirty="0">
                 <a:solidFill>
-                  <a:srgbClr val="545B64"/>
-                </a:solidFill>
-                <a:latin typeface="Calibri" pitchFamily="34" charset="0"/>
-                <a:ea typeface="Calibri" pitchFamily="34" charset="-122"/>
-                <a:cs typeface="Calibri" pitchFamily="34" charset="-120"/>
-              </a:rPr>
-              <a:t>GovCloud IaC variant included; the service stack is HIPAA-eligible where required. Confirm your agreement scope per service during the pilot's week one.</a:t>
+                  <a:srgbClr val="FFFFFF"/>
+                </a:solidFill>
+                <a:latin typeface="Calibri" pitchFamily="34" charset="0"/>
+                <a:ea typeface="Calibri" pitchFamily="34" charset="-122"/>
+                <a:cs typeface="Calibri" pitchFamily="34" charset="-120"/>
+              </a:rPr>
+              <a:t>standing still</a:t>
             </a:r>
             <a:endParaRPr lang="en-US" sz="1050" dirty="0"/>
           </a:p>
@@ -3687,7 +3778,246 @@
       </p:sp>
       <p:sp>
         <p:nvSpPr>
-          <p:cNvPr id="20" name="Text 18"/>
+          <p:cNvPr id="20" name="Shape 18"/>
+          <p:cNvSpPr/>
+          <p:nvPr/>
+        </p:nvSpPr>
+        <p:spPr>
+          <a:xfrm>
+            <a:off x="6172200" y="4343400"/>
+            <a:ext cx="2651760" cy="1143000"/>
+          </a:xfrm>
+          <a:prstGeom prst="roundRect">
+            <a:avLst>
+              <a:gd name="adj" fmla="val 4800"/>
+            </a:avLst>
+          </a:prstGeom>
+          <a:solidFill>
+            <a:srgbClr val="1B2A3A"/>
+          </a:solidFill>
+          <a:ln/>
+        </p:spPr>
+      </p:sp>
+      <p:sp>
+        <p:nvSpPr>
+          <p:cNvPr id="21" name="Text 19"/>
+          <p:cNvSpPr/>
+          <p:nvPr/>
+        </p:nvSpPr>
+        <p:spPr>
+          <a:xfrm>
+            <a:off x="6172200" y="4434840"/>
+            <a:ext cx="2651760" cy="548640"/>
+          </a:xfrm>
+          <a:prstGeom prst="rect">
+            <a:avLst/>
+          </a:prstGeom>
+          <a:noFill/>
+          <a:ln/>
+        </p:spPr>
+        <p:txBody>
+          <a:bodyPr wrap="square" lIns="0" tIns="0" rIns="0" bIns="0" rtlCol="0" anchor="ctr"/>
+          <a:lstStyle/>
+          <a:p>
+            <a:pPr algn="ctr" indent="0" marL="0">
+              <a:buNone/>
+            </a:pPr>
+            <a:r>
+              <a:rPr lang="en-US" sz="2600" b="1" dirty="0">
+                <a:solidFill>
+                  <a:srgbClr val="F3B23E"/>
+                </a:solidFill>
+                <a:latin typeface="Calibri" pitchFamily="34" charset="0"/>
+                <a:ea typeface="Calibri" pitchFamily="34" charset="-122"/>
+                <a:cs typeface="Calibri" pitchFamily="34" charset="-120"/>
+              </a:rPr>
+              <a:t>1</a:t>
+            </a:r>
+            <a:endParaRPr lang="en-US" sz="2600" dirty="0"/>
+          </a:p>
+        </p:txBody>
+      </p:sp>
+      <p:sp>
+        <p:nvSpPr>
+          <p:cNvPr id="22" name="Text 20"/>
+          <p:cNvSpPr/>
+          <p:nvPr/>
+        </p:nvSpPr>
+        <p:spPr>
+          <a:xfrm>
+            <a:off x="6263640" y="4983480"/>
+            <a:ext cx="2468880" cy="411480"/>
+          </a:xfrm>
+          <a:prstGeom prst="rect">
+            <a:avLst/>
+          </a:prstGeom>
+          <a:noFill/>
+          <a:ln/>
+        </p:spPr>
+        <p:txBody>
+          <a:bodyPr wrap="square" lIns="0" tIns="0" rIns="0" bIns="0" rtlCol="0" anchor="ctr"/>
+          <a:lstStyle/>
+          <a:p>
+            <a:pPr algn="ctr" indent="0" marL="0">
+              <a:buNone/>
+            </a:pPr>
+            <a:r>
+              <a:rPr lang="en-US" sz="1050" dirty="0">
+                <a:solidFill>
+                  <a:srgbClr val="FFFFFF"/>
+                </a:solidFill>
+                <a:latin typeface="Calibri" pitchFamily="34" charset="0"/>
+                <a:ea typeface="Calibri" pitchFamily="34" charset="-122"/>
+                <a:cs typeface="Calibri" pitchFamily="34" charset="-120"/>
+              </a:rPr>
+              <a:t>deploy (cdk deploy)</a:t>
+            </a:r>
+            <a:endParaRPr lang="en-US" sz="1050" dirty="0"/>
+          </a:p>
+        </p:txBody>
+      </p:sp>
+      <p:sp>
+        <p:nvSpPr>
+          <p:cNvPr id="23" name="Shape 21"/>
+          <p:cNvSpPr/>
+          <p:nvPr/>
+        </p:nvSpPr>
+        <p:spPr>
+          <a:xfrm>
+            <a:off x="8983980" y="4343400"/>
+            <a:ext cx="2651760" cy="1143000"/>
+          </a:xfrm>
+          <a:prstGeom prst="roundRect">
+            <a:avLst>
+              <a:gd name="adj" fmla="val 4800"/>
+            </a:avLst>
+          </a:prstGeom>
+          <a:solidFill>
+            <a:srgbClr val="1B2A3A"/>
+          </a:solidFill>
+          <a:ln/>
+        </p:spPr>
+      </p:sp>
+      <p:sp>
+        <p:nvSpPr>
+          <p:cNvPr id="24" name="Text 22"/>
+          <p:cNvSpPr/>
+          <p:nvPr/>
+        </p:nvSpPr>
+        <p:spPr>
+          <a:xfrm>
+            <a:off x="8983980" y="4434840"/>
+            <a:ext cx="2651760" cy="548640"/>
+          </a:xfrm>
+          <a:prstGeom prst="rect">
+            <a:avLst/>
+          </a:prstGeom>
+          <a:noFill/>
+          <a:ln/>
+        </p:spPr>
+        <p:txBody>
+          <a:bodyPr wrap="square" lIns="0" tIns="0" rIns="0" bIns="0" rtlCol="0" anchor="ctr"/>
+          <a:lstStyle/>
+          <a:p>
+            <a:pPr algn="ctr" indent="0" marL="0">
+              <a:buNone/>
+            </a:pPr>
+            <a:r>
+              <a:rPr lang="en-US" sz="2600" b="1" dirty="0">
+                <a:solidFill>
+                  <a:srgbClr val="F3B23E"/>
+                </a:solidFill>
+                <a:latin typeface="Calibri" pitchFamily="34" charset="0"/>
+                <a:ea typeface="Calibri" pitchFamily="34" charset="-122"/>
+                <a:cs typeface="Calibri" pitchFamily="34" charset="-120"/>
+              </a:rPr>
+              <a:t>~10</a:t>
+            </a:r>
+            <a:endParaRPr lang="en-US" sz="2600" dirty="0"/>
+          </a:p>
+        </p:txBody>
+      </p:sp>
+      <p:sp>
+        <p:nvSpPr>
+          <p:cNvPr id="25" name="Text 23"/>
+          <p:cNvSpPr/>
+          <p:nvPr/>
+        </p:nvSpPr>
+        <p:spPr>
+          <a:xfrm>
+            <a:off x="9075420" y="4983480"/>
+            <a:ext cx="2468880" cy="411480"/>
+          </a:xfrm>
+          <a:prstGeom prst="rect">
+            <a:avLst/>
+          </a:prstGeom>
+          <a:noFill/>
+          <a:ln/>
+        </p:spPr>
+        <p:txBody>
+          <a:bodyPr wrap="square" lIns="0" tIns="0" rIns="0" bIns="0" rtlCol="0" anchor="ctr"/>
+          <a:lstStyle/>
+          <a:p>
+            <a:pPr algn="ctr" indent="0" marL="0">
+              <a:buNone/>
+            </a:pPr>
+            <a:r>
+              <a:rPr lang="en-US" sz="1050" dirty="0">
+                <a:solidFill>
+                  <a:srgbClr val="FFFFFF"/>
+                </a:solidFill>
+                <a:latin typeface="Calibri" pitchFamily="34" charset="0"/>
+                <a:ea typeface="Calibri" pitchFamily="34" charset="-122"/>
+                <a:cs typeface="Calibri" pitchFamily="34" charset="-120"/>
+              </a:rPr>
+              <a:t>decisions you actually make</a:t>
+            </a:r>
+            <a:endParaRPr lang="en-US" sz="1050" dirty="0"/>
+          </a:p>
+        </p:txBody>
+      </p:sp>
+      <p:sp>
+        <p:nvSpPr>
+          <p:cNvPr id="26" name="Text 24"/>
+          <p:cNvSpPr/>
+          <p:nvPr/>
+        </p:nvSpPr>
+        <p:spPr>
+          <a:xfrm>
+            <a:off x="548640" y="5715000"/>
+            <a:ext cx="11064240" cy="411480"/>
+          </a:xfrm>
+          <a:prstGeom prst="rect">
+            <a:avLst/>
+          </a:prstGeom>
+          <a:noFill/>
+          <a:ln/>
+        </p:spPr>
+        <p:txBody>
+          <a:bodyPr wrap="square" lIns="0" tIns="0" rIns="0" bIns="0" rtlCol="0" anchor="ctr"/>
+          <a:lstStyle/>
+          <a:p>
+            <a:pPr algn="ctr" indent="0" marL="0">
+              <a:buNone/>
+            </a:pPr>
+            <a:r>
+              <a:rPr lang="en-US" sz="1400" b="1" i="1" dirty="0">
+                <a:solidFill>
+                  <a:srgbClr val="0B6E4F"/>
+                </a:solidFill>
+                <a:latin typeface="Calibri" pitchFamily="34" charset="0"/>
+                <a:ea typeface="Calibri" pitchFamily="34" charset="-122"/>
+                <a:cs typeface="Calibri" pitchFamily="34" charset="-120"/>
+              </a:rPr>
+              <a:t>You don't operate thirty services. You answer three questions — and the stack answers back with evidence.</a:t>
+            </a:r>
+            <a:endParaRPr lang="en-US" sz="1400" dirty="0"/>
+          </a:p>
+        </p:txBody>
+      </p:sp>
+      <p:sp>
+        <p:nvSpPr>
+          <p:cNvPr id="27" name="Text 25"/>
           <p:cNvSpPr/>
           <p:nvPr/>
         </p:nvSpPr>
@@ -3726,7 +4056,7 @@
       </p:sp>
       <p:sp>
         <p:nvSpPr>
-          <p:cNvPr id="21" name="Text 19"/>
+          <p:cNvPr id="28" name="Text 26"/>
           <p:cNvSpPr/>
           <p:nvPr/>
         </p:nvSpPr>
@@ -3757,7 +4087,7 @@
                 <a:ea typeface="Calibri" pitchFamily="34" charset="-122"/>
                 <a:cs typeface="Calibri" pitchFamily="34" charset="-120"/>
               </a:rPr>
-              <a:t>11 / 12</a:t>
+              <a:t>11 / 13</a:t>
             </a:r>
             <a:endParaRPr lang="en-US" sz="900" dirty="0"/>
           </a:p>
@@ -3774,6 +4104,719 @@
 <file path=ppt/slides/slide12.xml><?xml version="1.0" encoding="utf-8"?>
 <p:sld xmlns:a="http://schemas.openxmlformats.org/drawingml/2006/main" xmlns:r="http://schemas.openxmlformats.org/officeDocument/2006/relationships" xmlns:p="http://schemas.openxmlformats.org/presentationml/2006/main">
   <p:cSld name="Slide 12">
+    <p:spTree>
+      <p:nvGrpSpPr>
+        <p:cNvPr id="1" name=""/>
+        <p:cNvGrpSpPr/>
+        <p:nvPr/>
+      </p:nvGrpSpPr>
+      <p:grpSpPr>
+        <a:xfrm>
+          <a:off x="0" y="0"/>
+          <a:ext cx="0" cy="0"/>
+          <a:chOff x="0" y="0"/>
+          <a:chExt cx="0" cy="0"/>
+        </a:xfrm>
+      </p:grpSpPr>
+      <p:sp>
+        <p:nvSpPr>
+          <p:cNvPr id="2" name="Text 0"/>
+          <p:cNvSpPr/>
+          <p:nvPr/>
+        </p:nvSpPr>
+        <p:spPr>
+          <a:xfrm>
+            <a:off x="548640" y="384048"/>
+            <a:ext cx="8229600" cy="292608"/>
+          </a:xfrm>
+          <a:prstGeom prst="rect">
+            <a:avLst/>
+          </a:prstGeom>
+          <a:noFill/>
+          <a:ln/>
+        </p:spPr>
+        <p:txBody>
+          <a:bodyPr wrap="square" lIns="0" tIns="0" rIns="0" bIns="0" rtlCol="0" anchor="ctr"/>
+          <a:lstStyle/>
+          <a:p>
+            <a:pPr indent="0" marL="0">
+              <a:buNone/>
+            </a:pPr>
+            <a:r>
+              <a:rPr lang="en-US" sz="1200" b="1" spc="200" kern="0" dirty="0">
+                <a:solidFill>
+                  <a:srgbClr val="0B6E4F"/>
+                </a:solidFill>
+                <a:latin typeface="Calibri" pitchFamily="34" charset="0"/>
+                <a:ea typeface="Calibri" pitchFamily="34" charset="-122"/>
+                <a:cs typeface="Calibri" pitchFamily="34" charset="-120"/>
+              </a:rPr>
+              <a:t>08 · STRAIGHT ANSWERS</a:t>
+            </a:r>
+            <a:endParaRPr lang="en-US" sz="1200" dirty="0"/>
+          </a:p>
+        </p:txBody>
+      </p:sp>
+      <p:sp>
+        <p:nvSpPr>
+          <p:cNvPr id="3" name="Text 1"/>
+          <p:cNvSpPr/>
+          <p:nvPr/>
+        </p:nvSpPr>
+        <p:spPr>
+          <a:xfrm>
+            <a:off x="548640" y="658368"/>
+            <a:ext cx="11064240" cy="685800"/>
+          </a:xfrm>
+          <a:prstGeom prst="rect">
+            <a:avLst/>
+          </a:prstGeom>
+          <a:noFill/>
+          <a:ln/>
+        </p:spPr>
+        <p:txBody>
+          <a:bodyPr wrap="square" lIns="0" tIns="0" rIns="0" bIns="0" rtlCol="0" anchor="ctr"/>
+          <a:lstStyle/>
+          <a:p>
+            <a:pPr indent="0" marL="0">
+              <a:buNone/>
+            </a:pPr>
+            <a:r>
+              <a:rPr lang="en-US" sz="3000" b="1" dirty="0">
+                <a:solidFill>
+                  <a:srgbClr val="1B2A3A"/>
+                </a:solidFill>
+                <a:latin typeface="Calibri" pitchFamily="34" charset="0"/>
+                <a:ea typeface="Calibri" pitchFamily="34" charset="-122"/>
+                <a:cs typeface="Calibri" pitchFamily="34" charset="-120"/>
+              </a:rPr>
+              <a:t>The Questions You Should Ask Us</a:t>
+            </a:r>
+            <a:endParaRPr lang="en-US" sz="3000" dirty="0"/>
+          </a:p>
+        </p:txBody>
+      </p:sp>
+      <p:sp>
+        <p:nvSpPr>
+          <p:cNvPr id="4" name="Shape 2"/>
+          <p:cNvSpPr/>
+          <p:nvPr/>
+        </p:nvSpPr>
+        <p:spPr>
+          <a:xfrm>
+            <a:off x="548640" y="1600200"/>
+            <a:ext cx="3291840" cy="1005840"/>
+          </a:xfrm>
+          <a:prstGeom prst="roundRect">
+            <a:avLst>
+              <a:gd name="adj" fmla="val 4545"/>
+            </a:avLst>
+          </a:prstGeom>
+          <a:solidFill>
+            <a:srgbClr val="1B2A3A"/>
+          </a:solidFill>
+          <a:ln/>
+        </p:spPr>
+      </p:sp>
+      <p:sp>
+        <p:nvSpPr>
+          <p:cNvPr id="5" name="Text 3"/>
+          <p:cNvSpPr/>
+          <p:nvPr/>
+        </p:nvSpPr>
+        <p:spPr>
+          <a:xfrm>
+            <a:off x="713232" y="1600200"/>
+            <a:ext cx="2971800" cy="1005840"/>
+          </a:xfrm>
+          <a:prstGeom prst="rect">
+            <a:avLst/>
+          </a:prstGeom>
+          <a:noFill/>
+          <a:ln/>
+        </p:spPr>
+        <p:txBody>
+          <a:bodyPr wrap="square" lIns="0" tIns="0" rIns="0" bIns="0" rtlCol="0" anchor="ctr"/>
+          <a:lstStyle/>
+          <a:p>
+            <a:pPr indent="0" marL="0">
+              <a:lnSpc>
+                <a:spcPct val="105000"/>
+              </a:lnSpc>
+              <a:buNone/>
+            </a:pPr>
+            <a:r>
+              <a:rPr lang="en-US" sz="1200" b="1" dirty="0">
+                <a:solidFill>
+                  <a:srgbClr val="FFFFFF"/>
+                </a:solidFill>
+                <a:latin typeface="Calibri" pitchFamily="34" charset="0"/>
+                <a:ea typeface="Calibri" pitchFamily="34" charset="-122"/>
+                <a:cs typeface="Calibri" pitchFamily="34" charset="-120"/>
+              </a:rPr>
+              <a:t>“Is this an official product?”</a:t>
+            </a:r>
+            <a:endParaRPr lang="en-US" sz="1200" dirty="0"/>
+          </a:p>
+        </p:txBody>
+      </p:sp>
+      <p:sp>
+        <p:nvSpPr>
+          <p:cNvPr id="6" name="Shape 4"/>
+          <p:cNvSpPr/>
+          <p:nvPr/>
+        </p:nvSpPr>
+        <p:spPr>
+          <a:xfrm>
+            <a:off x="3931920" y="1600200"/>
+            <a:ext cx="7726680" cy="1005840"/>
+          </a:xfrm>
+          <a:prstGeom prst="roundRect">
+            <a:avLst>
+              <a:gd name="adj" fmla="val 4545"/>
+            </a:avLst>
+          </a:prstGeom>
+          <a:solidFill>
+            <a:srgbClr val="F2F3F3"/>
+          </a:solidFill>
+          <a:ln w="9525">
+            <a:solidFill>
+              <a:srgbClr val="D5DBDB"/>
+            </a:solidFill>
+            <a:prstDash val="solid"/>
+          </a:ln>
+        </p:spPr>
+      </p:sp>
+      <p:sp>
+        <p:nvSpPr>
+          <p:cNvPr id="7" name="Text 5"/>
+          <p:cNvSpPr/>
+          <p:nvPr/>
+        </p:nvSpPr>
+        <p:spPr>
+          <a:xfrm>
+            <a:off x="4096512" y="1655064"/>
+            <a:ext cx="7406640" cy="914400"/>
+          </a:xfrm>
+          <a:prstGeom prst="rect">
+            <a:avLst/>
+          </a:prstGeom>
+          <a:noFill/>
+          <a:ln/>
+        </p:spPr>
+        <p:txBody>
+          <a:bodyPr wrap="square" lIns="0" tIns="0" rIns="0" bIns="0" rtlCol="0" anchor="ctr"/>
+          <a:lstStyle/>
+          <a:p>
+            <a:pPr indent="0" marL="0">
+              <a:lnSpc>
+                <a:spcPct val="105000"/>
+              </a:lnSpc>
+              <a:buNone/>
+            </a:pPr>
+            <a:r>
+              <a:rPr lang="en-US" sz="1050" dirty="0">
+                <a:solidFill>
+                  <a:srgbClr val="545B64"/>
+                </a:solidFill>
+                <a:latin typeface="Calibri" pitchFamily="34" charset="0"/>
+                <a:ea typeface="Calibri" pitchFamily="34" charset="-122"/>
+                <a:cs typeface="Calibri" pitchFamily="34" charset="-120"/>
+              </a:rPr>
+              <a:t>No — and the repo says so in writing (NOT-CLAIMS). It's an open reference architecture built on AWS services: you fork it, review every line, and own what you run. No lock-in, no license fee, no black box.</a:t>
+            </a:r>
+            <a:endParaRPr lang="en-US" sz="1050" dirty="0"/>
+          </a:p>
+        </p:txBody>
+      </p:sp>
+      <p:sp>
+        <p:nvSpPr>
+          <p:cNvPr id="8" name="Shape 6"/>
+          <p:cNvSpPr/>
+          <p:nvPr/>
+        </p:nvSpPr>
+        <p:spPr>
+          <a:xfrm>
+            <a:off x="548640" y="2734056"/>
+            <a:ext cx="3291840" cy="1005840"/>
+          </a:xfrm>
+          <a:prstGeom prst="roundRect">
+            <a:avLst>
+              <a:gd name="adj" fmla="val 4545"/>
+            </a:avLst>
+          </a:prstGeom>
+          <a:solidFill>
+            <a:srgbClr val="1B2A3A"/>
+          </a:solidFill>
+          <a:ln/>
+        </p:spPr>
+      </p:sp>
+      <p:sp>
+        <p:nvSpPr>
+          <p:cNvPr id="9" name="Text 7"/>
+          <p:cNvSpPr/>
+          <p:nvPr/>
+        </p:nvSpPr>
+        <p:spPr>
+          <a:xfrm>
+            <a:off x="713232" y="2734056"/>
+            <a:ext cx="2971800" cy="1005840"/>
+          </a:xfrm>
+          <a:prstGeom prst="rect">
+            <a:avLst/>
+          </a:prstGeom>
+          <a:noFill/>
+          <a:ln/>
+        </p:spPr>
+        <p:txBody>
+          <a:bodyPr wrap="square" lIns="0" tIns="0" rIns="0" bIns="0" rtlCol="0" anchor="ctr"/>
+          <a:lstStyle/>
+          <a:p>
+            <a:pPr indent="0" marL="0">
+              <a:lnSpc>
+                <a:spcPct val="105000"/>
+              </a:lnSpc>
+              <a:buNone/>
+            </a:pPr>
+            <a:r>
+              <a:rPr lang="en-US" sz="1200" b="1" dirty="0">
+                <a:solidFill>
+                  <a:srgbClr val="FFFFFF"/>
+                </a:solidFill>
+                <a:latin typeface="Calibri" pitchFamily="34" charset="0"/>
+                <a:ea typeface="Calibri" pitchFamily="34" charset="-122"/>
+                <a:cs typeface="Calibri" pitchFamily="34" charset="-120"/>
+              </a:rPr>
+              <a:t>“We already have IAM / a WAF / audit logs.”</a:t>
+            </a:r>
+            <a:endParaRPr lang="en-US" sz="1200" dirty="0"/>
+          </a:p>
+        </p:txBody>
+      </p:sp>
+      <p:sp>
+        <p:nvSpPr>
+          <p:cNvPr id="10" name="Shape 8"/>
+          <p:cNvSpPr/>
+          <p:nvPr/>
+        </p:nvSpPr>
+        <p:spPr>
+          <a:xfrm>
+            <a:off x="3931920" y="2734056"/>
+            <a:ext cx="7726680" cy="1005840"/>
+          </a:xfrm>
+          <a:prstGeom prst="roundRect">
+            <a:avLst>
+              <a:gd name="adj" fmla="val 4545"/>
+            </a:avLst>
+          </a:prstGeom>
+          <a:solidFill>
+            <a:srgbClr val="F2F3F3"/>
+          </a:solidFill>
+          <a:ln w="9525">
+            <a:solidFill>
+              <a:srgbClr val="D5DBDB"/>
+            </a:solidFill>
+            <a:prstDash val="solid"/>
+          </a:ln>
+        </p:spPr>
+      </p:sp>
+      <p:sp>
+        <p:nvSpPr>
+          <p:cNvPr id="11" name="Text 9"/>
+          <p:cNvSpPr/>
+          <p:nvPr/>
+        </p:nvSpPr>
+        <p:spPr>
+          <a:xfrm>
+            <a:off x="4096512" y="2788920"/>
+            <a:ext cx="7406640" cy="914400"/>
+          </a:xfrm>
+          <a:prstGeom prst="rect">
+            <a:avLst/>
+          </a:prstGeom>
+          <a:noFill/>
+          <a:ln/>
+        </p:spPr>
+        <p:txBody>
+          <a:bodyPr wrap="square" lIns="0" tIns="0" rIns="0" bIns="0" rtlCol="0" anchor="ctr"/>
+          <a:lstStyle/>
+          <a:p>
+            <a:pPr indent="0" marL="0">
+              <a:lnSpc>
+                <a:spcPct val="105000"/>
+              </a:lnSpc>
+              <a:buNone/>
+            </a:pPr>
+            <a:r>
+              <a:rPr lang="en-US" sz="1050" dirty="0">
+                <a:solidFill>
+                  <a:srgbClr val="545B64"/>
+                </a:solidFill>
+                <a:latin typeface="Calibri" pitchFamily="34" charset="0"/>
+                <a:ea typeface="Calibri" pitchFamily="34" charset="-122"/>
+                <a:cs typeface="Calibri" pitchFamily="34" charset="-120"/>
+              </a:rPr>
+              <a:t>Keep them — the platform composes them. What you're missing is the agent-specific layer: agent∩human intersection, consequential-action gates, prompt-boundary masking, per-agent budgets, and one audit spine across departments.</a:t>
+            </a:r>
+            <a:endParaRPr lang="en-US" sz="1050" dirty="0"/>
+          </a:p>
+        </p:txBody>
+      </p:sp>
+      <p:sp>
+        <p:nvSpPr>
+          <p:cNvPr id="12" name="Shape 10"/>
+          <p:cNvSpPr/>
+          <p:nvPr/>
+        </p:nvSpPr>
+        <p:spPr>
+          <a:xfrm>
+            <a:off x="548640" y="3867912"/>
+            <a:ext cx="3291840" cy="1005840"/>
+          </a:xfrm>
+          <a:prstGeom prst="roundRect">
+            <a:avLst>
+              <a:gd name="adj" fmla="val 4545"/>
+            </a:avLst>
+          </a:prstGeom>
+          <a:solidFill>
+            <a:srgbClr val="1B2A3A"/>
+          </a:solidFill>
+          <a:ln/>
+        </p:spPr>
+      </p:sp>
+      <p:sp>
+        <p:nvSpPr>
+          <p:cNvPr id="13" name="Text 11"/>
+          <p:cNvSpPr/>
+          <p:nvPr/>
+        </p:nvSpPr>
+        <p:spPr>
+          <a:xfrm>
+            <a:off x="713232" y="3867912"/>
+            <a:ext cx="2971800" cy="1005840"/>
+          </a:xfrm>
+          <a:prstGeom prst="rect">
+            <a:avLst/>
+          </a:prstGeom>
+          <a:noFill/>
+          <a:ln/>
+        </p:spPr>
+        <p:txBody>
+          <a:bodyPr wrap="square" lIns="0" tIns="0" rIns="0" bIns="0" rtlCol="0" anchor="ctr"/>
+          <a:lstStyle/>
+          <a:p>
+            <a:pPr indent="0" marL="0">
+              <a:lnSpc>
+                <a:spcPct val="105000"/>
+              </a:lnSpc>
+              <a:buNone/>
+            </a:pPr>
+            <a:r>
+              <a:rPr lang="en-US" sz="1200" b="1" dirty="0">
+                <a:solidFill>
+                  <a:srgbClr val="FFFFFF"/>
+                </a:solidFill>
+                <a:latin typeface="Calibri" pitchFamily="34" charset="0"/>
+                <a:ea typeface="Calibri" pitchFamily="34" charset="-122"/>
+                <a:cs typeface="Calibri" pitchFamily="34" charset="-120"/>
+              </a:rPr>
+              <a:t>“Can our existing agents fit?”</a:t>
+            </a:r>
+            <a:endParaRPr lang="en-US" sz="1200" dirty="0"/>
+          </a:p>
+        </p:txBody>
+      </p:sp>
+      <p:sp>
+        <p:nvSpPr>
+          <p:cNvPr id="14" name="Shape 12"/>
+          <p:cNvSpPr/>
+          <p:nvPr/>
+        </p:nvSpPr>
+        <p:spPr>
+          <a:xfrm>
+            <a:off x="3931920" y="3867912"/>
+            <a:ext cx="7726680" cy="1005840"/>
+          </a:xfrm>
+          <a:prstGeom prst="roundRect">
+            <a:avLst>
+              <a:gd name="adj" fmla="val 4545"/>
+            </a:avLst>
+          </a:prstGeom>
+          <a:solidFill>
+            <a:srgbClr val="F2F3F3"/>
+          </a:solidFill>
+          <a:ln w="9525">
+            <a:solidFill>
+              <a:srgbClr val="D5DBDB"/>
+            </a:solidFill>
+            <a:prstDash val="solid"/>
+          </a:ln>
+        </p:spPr>
+      </p:sp>
+      <p:sp>
+        <p:nvSpPr>
+          <p:cNvPr id="15" name="Text 13"/>
+          <p:cNvSpPr/>
+          <p:nvPr/>
+        </p:nvSpPr>
+        <p:spPr>
+          <a:xfrm>
+            <a:off x="4096512" y="3922776"/>
+            <a:ext cx="7406640" cy="914400"/>
+          </a:xfrm>
+          <a:prstGeom prst="rect">
+            <a:avLst/>
+          </a:prstGeom>
+          <a:noFill/>
+          <a:ln/>
+        </p:spPr>
+        <p:txBody>
+          <a:bodyPr wrap="square" lIns="0" tIns="0" rIns="0" bIns="0" rtlCol="0" anchor="ctr"/>
+          <a:lstStyle/>
+          <a:p>
+            <a:pPr indent="0" marL="0">
+              <a:lnSpc>
+                <a:spcPct val="105000"/>
+              </a:lnSpc>
+              <a:buNone/>
+            </a:pPr>
+            <a:r>
+              <a:rPr lang="en-US" sz="1050" dirty="0">
+                <a:solidFill>
+                  <a:srgbClr val="545B64"/>
+                </a:solidFill>
+                <a:latin typeface="Calibri" pitchFamily="34" charset="0"/>
+                <a:ea typeface="Calibri" pitchFamily="34" charset="-122"/>
+                <a:cs typeface="Calibri" pitchFamily="34" charset="-120"/>
+              </a:rPr>
+              <a:t>If they can declare a manifest and clear the nine gates, yes. The bar is the retrofit checklist — most agents fail on scope declaration and the human gate first, and both are fixable.</a:t>
+            </a:r>
+            <a:endParaRPr lang="en-US" sz="1050" dirty="0"/>
+          </a:p>
+        </p:txBody>
+      </p:sp>
+      <p:sp>
+        <p:nvSpPr>
+          <p:cNvPr id="16" name="Shape 14"/>
+          <p:cNvSpPr/>
+          <p:nvPr/>
+        </p:nvSpPr>
+        <p:spPr>
+          <a:xfrm>
+            <a:off x="548640" y="5001768"/>
+            <a:ext cx="3291840" cy="1005840"/>
+          </a:xfrm>
+          <a:prstGeom prst="roundRect">
+            <a:avLst>
+              <a:gd name="adj" fmla="val 4545"/>
+            </a:avLst>
+          </a:prstGeom>
+          <a:solidFill>
+            <a:srgbClr val="1B2A3A"/>
+          </a:solidFill>
+          <a:ln/>
+        </p:spPr>
+      </p:sp>
+      <p:sp>
+        <p:nvSpPr>
+          <p:cNvPr id="17" name="Text 15"/>
+          <p:cNvSpPr/>
+          <p:nvPr/>
+        </p:nvSpPr>
+        <p:spPr>
+          <a:xfrm>
+            <a:off x="713232" y="5001768"/>
+            <a:ext cx="2971800" cy="1005840"/>
+          </a:xfrm>
+          <a:prstGeom prst="rect">
+            <a:avLst/>
+          </a:prstGeom>
+          <a:noFill/>
+          <a:ln/>
+        </p:spPr>
+        <p:txBody>
+          <a:bodyPr wrap="square" lIns="0" tIns="0" rIns="0" bIns="0" rtlCol="0" anchor="ctr"/>
+          <a:lstStyle/>
+          <a:p>
+            <a:pPr indent="0" marL="0">
+              <a:lnSpc>
+                <a:spcPct val="105000"/>
+              </a:lnSpc>
+              <a:buNone/>
+            </a:pPr>
+            <a:r>
+              <a:rPr lang="en-US" sz="1200" b="1" dirty="0">
+                <a:solidFill>
+                  <a:srgbClr val="FFFFFF"/>
+                </a:solidFill>
+                <a:latin typeface="Calibri" pitchFamily="34" charset="0"/>
+                <a:ea typeface="Calibri" pitchFamily="34" charset="-122"/>
+                <a:cs typeface="Calibri" pitchFamily="34" charset="-120"/>
+              </a:rPr>
+              <a:t>“What about GovCloud / our BAA?”</a:t>
+            </a:r>
+            <a:endParaRPr lang="en-US" sz="1200" dirty="0"/>
+          </a:p>
+        </p:txBody>
+      </p:sp>
+      <p:sp>
+        <p:nvSpPr>
+          <p:cNvPr id="18" name="Shape 16"/>
+          <p:cNvSpPr/>
+          <p:nvPr/>
+        </p:nvSpPr>
+        <p:spPr>
+          <a:xfrm>
+            <a:off x="3931920" y="5001768"/>
+            <a:ext cx="7726680" cy="1005840"/>
+          </a:xfrm>
+          <a:prstGeom prst="roundRect">
+            <a:avLst>
+              <a:gd name="adj" fmla="val 4545"/>
+            </a:avLst>
+          </a:prstGeom>
+          <a:solidFill>
+            <a:srgbClr val="F2F3F3"/>
+          </a:solidFill>
+          <a:ln w="9525">
+            <a:solidFill>
+              <a:srgbClr val="D5DBDB"/>
+            </a:solidFill>
+            <a:prstDash val="solid"/>
+          </a:ln>
+        </p:spPr>
+      </p:sp>
+      <p:sp>
+        <p:nvSpPr>
+          <p:cNvPr id="19" name="Text 17"/>
+          <p:cNvSpPr/>
+          <p:nvPr/>
+        </p:nvSpPr>
+        <p:spPr>
+          <a:xfrm>
+            <a:off x="4096512" y="5056632"/>
+            <a:ext cx="7406640" cy="914400"/>
+          </a:xfrm>
+          <a:prstGeom prst="rect">
+            <a:avLst/>
+          </a:prstGeom>
+          <a:noFill/>
+          <a:ln/>
+        </p:spPr>
+        <p:txBody>
+          <a:bodyPr wrap="square" lIns="0" tIns="0" rIns="0" bIns="0" rtlCol="0" anchor="ctr"/>
+          <a:lstStyle/>
+          <a:p>
+            <a:pPr indent="0" marL="0">
+              <a:lnSpc>
+                <a:spcPct val="105000"/>
+              </a:lnSpc>
+              <a:buNone/>
+            </a:pPr>
+            <a:r>
+              <a:rPr lang="en-US" sz="1050" dirty="0">
+                <a:solidFill>
+                  <a:srgbClr val="545B64"/>
+                </a:solidFill>
+                <a:latin typeface="Calibri" pitchFamily="34" charset="0"/>
+                <a:ea typeface="Calibri" pitchFamily="34" charset="-122"/>
+                <a:cs typeface="Calibri" pitchFamily="34" charset="-120"/>
+              </a:rPr>
+              <a:t>GovCloud IaC variant included; the service stack is HIPAA-eligible where required. Confirm your agreement scope per service during the pilot's week one.</a:t>
+            </a:r>
+            <a:endParaRPr lang="en-US" sz="1050" dirty="0"/>
+          </a:p>
+        </p:txBody>
+      </p:sp>
+      <p:sp>
+        <p:nvSpPr>
+          <p:cNvPr id="20" name="Text 18"/>
+          <p:cNvSpPr/>
+          <p:nvPr/>
+        </p:nvSpPr>
+        <p:spPr>
+          <a:xfrm>
+            <a:off x="548640" y="6473952"/>
+            <a:ext cx="8686800" cy="274320"/>
+          </a:xfrm>
+          <a:prstGeom prst="rect">
+            <a:avLst/>
+          </a:prstGeom>
+          <a:noFill/>
+          <a:ln/>
+        </p:spPr>
+        <p:txBody>
+          <a:bodyPr wrap="square" lIns="0" tIns="0" rIns="0" bIns="0" rtlCol="0" anchor="ctr"/>
+          <a:lstStyle/>
+          <a:p>
+            <a:pPr indent="0" marL="0">
+              <a:buNone/>
+            </a:pPr>
+            <a:r>
+              <a:rPr lang="en-US" sz="900" dirty="0">
+                <a:solidFill>
+                  <a:srgbClr val="879196"/>
+                </a:solidFill>
+                <a:latin typeface="Calibri" pitchFamily="34" charset="0"/>
+                <a:ea typeface="Calibri" pitchFamily="34" charset="-122"/>
+                <a:cs typeface="Calibri" pitchFamily="34" charset="-120"/>
+              </a:rPr>
+              <a:t>Aegis — Governed AI Agents · Built on AWS · Reference architecture (see NOT-CLAIMS)</a:t>
+            </a:r>
+            <a:endParaRPr lang="en-US" sz="900" dirty="0"/>
+          </a:p>
+        </p:txBody>
+      </p:sp>
+      <p:sp>
+        <p:nvSpPr>
+          <p:cNvPr id="21" name="Text 19"/>
+          <p:cNvSpPr/>
+          <p:nvPr/>
+        </p:nvSpPr>
+        <p:spPr>
+          <a:xfrm>
+            <a:off x="10908792" y="6473952"/>
+            <a:ext cx="731520" cy="274320"/>
+          </a:xfrm>
+          <a:prstGeom prst="rect">
+            <a:avLst/>
+          </a:prstGeom>
+          <a:noFill/>
+          <a:ln/>
+        </p:spPr>
+        <p:txBody>
+          <a:bodyPr wrap="square" lIns="0" tIns="0" rIns="0" bIns="0" rtlCol="0" anchor="ctr"/>
+          <a:lstStyle/>
+          <a:p>
+            <a:pPr algn="r" indent="0" marL="0">
+              <a:buNone/>
+            </a:pPr>
+            <a:r>
+              <a:rPr lang="en-US" sz="900" dirty="0">
+                <a:solidFill>
+                  <a:srgbClr val="879196"/>
+                </a:solidFill>
+                <a:latin typeface="Calibri" pitchFamily="34" charset="0"/>
+                <a:ea typeface="Calibri" pitchFamily="34" charset="-122"/>
+                <a:cs typeface="Calibri" pitchFamily="34" charset="-120"/>
+              </a:rPr>
+              <a:t>12 / 13</a:t>
+            </a:r>
+            <a:endParaRPr lang="en-US" sz="900" dirty="0"/>
+          </a:p>
+        </p:txBody>
+      </p:sp>
+    </p:spTree>
+  </p:cSld>
+  <p:clrMapOvr>
+    <a:masterClrMapping/>
+  </p:clrMapOvr>
+</p:sld>
+</file>
+
+<file path=ppt/slides/slide13.xml><?xml version="1.0" encoding="utf-8"?>
+<p:sld xmlns:a="http://schemas.openxmlformats.org/drawingml/2006/main" xmlns:r="http://schemas.openxmlformats.org/officeDocument/2006/relationships" xmlns:p="http://schemas.openxmlformats.org/presentationml/2006/main">
+  <p:cSld name="Slide 13">
     <p:bg>
       <p:bgPr>
         <a:solidFill>
@@ -5066,7 +6109,7 @@
                 <a:ea typeface="Calibri" pitchFamily="34" charset="-122"/>
                 <a:cs typeface="Calibri" pitchFamily="34" charset="-120"/>
               </a:rPr>
-              <a:t>2 / 12</a:t>
+              <a:t>2 / 13</a:t>
             </a:r>
             <a:endParaRPr lang="en-US" sz="900" dirty="0"/>
           </a:p>
@@ -6307,7 +7350,7 @@
                 <a:ea typeface="Calibri" pitchFamily="34" charset="-122"/>
                 <a:cs typeface="Calibri" pitchFamily="34" charset="-120"/>
               </a:rPr>
-              <a:t>3 / 12</a:t>
+              <a:t>3 / 13</a:t>
             </a:r>
             <a:endParaRPr lang="en-US" sz="900" dirty="0"/>
           </a:p>
@@ -8071,7 +9114,7 @@
                 <a:ea typeface="Calibri" pitchFamily="34" charset="-122"/>
                 <a:cs typeface="Calibri" pitchFamily="34" charset="-120"/>
               </a:rPr>
-              <a:t>4 / 12</a:t>
+              <a:t>4 / 13</a:t>
             </a:r>
             <a:endParaRPr lang="en-US" sz="900" dirty="0"/>
           </a:p>
@@ -9479,7 +10522,7 @@
                 <a:ea typeface="Calibri" pitchFamily="34" charset="-122"/>
                 <a:cs typeface="Calibri" pitchFamily="34" charset="-120"/>
               </a:rPr>
-              <a:t>5 / 12</a:t>
+              <a:t>5 / 13</a:t>
             </a:r>
             <a:endParaRPr lang="en-US" sz="900" dirty="0"/>
           </a:p>
@@ -10395,7 +11438,7 @@
                 <a:ea typeface="Calibri" pitchFamily="34" charset="-122"/>
                 <a:cs typeface="Calibri" pitchFamily="34" charset="-120"/>
               </a:rPr>
-              <a:t>6 / 12</a:t>
+              <a:t>6 / 13</a:t>
             </a:r>
             <a:endParaRPr lang="en-US" sz="900" dirty="0"/>
           </a:p>
@@ -11008,7 +12051,7 @@
                 <a:ea typeface="Calibri" pitchFamily="34" charset="-122"/>
                 <a:cs typeface="Calibri" pitchFamily="34" charset="-120"/>
               </a:rPr>
-              <a:t>7 / 12</a:t>
+              <a:t>7 / 13</a:t>
             </a:r>
             <a:endParaRPr lang="en-US" sz="900" dirty="0"/>
           </a:p>
@@ -11621,7 +12664,7 @@
                 <a:ea typeface="Calibri" pitchFamily="34" charset="-122"/>
                 <a:cs typeface="Calibri" pitchFamily="34" charset="-120"/>
               </a:rPr>
-              <a:t>8 / 12</a:t>
+              <a:t>8 / 13</a:t>
             </a:r>
             <a:endParaRPr lang="en-US" sz="900" dirty="0"/>
           </a:p>
@@ -12348,7 +13391,7 @@
                 <a:ea typeface="Calibri" pitchFamily="34" charset="-122"/>
                 <a:cs typeface="Calibri" pitchFamily="34" charset="-120"/>
               </a:rPr>
-              <a:t>9 / 12</a:t>
+              <a:t>9 / 13</a:t>
             </a:r>
             <a:endParaRPr lang="en-US" sz="900" dirty="0"/>
           </a:p>

</xml_diff>